<commit_message>
updated powerpoint to add images for using in presentations
</commit_message>
<xml_diff>
--- a/Design/ico-sysml-connector.pptx
+++ b/Design/ico-sysml-connector.pptx
@@ -10,6 +10,8 @@
     <p:sldId id="259" r:id="rId4"/>
     <p:sldId id="260" r:id="rId5"/>
     <p:sldId id="262" r:id="rId6"/>
+    <p:sldId id="263" r:id="rId7"/>
+    <p:sldId id="264" r:id="rId8"/>
   </p:sldIdLst>
   <p:sldSz cx="2743200" cy="2743200"/>
   <p:notesSz cx="6858000" cy="9144000"/>
@@ -247,7 +249,7 @@
           <a:p>
             <a:fld id="{F2DEBFF9-250A-4D6B-B7B3-3F1E7C2640FE}" type="datetimeFigureOut">
               <a:rPr lang="en-US" smtClean="0"/>
-              <a:t>5/7/2024</a:t>
+              <a:t>5/21/2024</a:t>
             </a:fld>
             <a:endParaRPr lang="en-US"/>
           </a:p>
@@ -417,7 +419,7 @@
           <a:p>
             <a:fld id="{F2DEBFF9-250A-4D6B-B7B3-3F1E7C2640FE}" type="datetimeFigureOut">
               <a:rPr lang="en-US" smtClean="0"/>
-              <a:t>5/7/2024</a:t>
+              <a:t>5/21/2024</a:t>
             </a:fld>
             <a:endParaRPr lang="en-US"/>
           </a:p>
@@ -597,7 +599,7 @@
           <a:p>
             <a:fld id="{F2DEBFF9-250A-4D6B-B7B3-3F1E7C2640FE}" type="datetimeFigureOut">
               <a:rPr lang="en-US" smtClean="0"/>
-              <a:t>5/7/2024</a:t>
+              <a:t>5/21/2024</a:t>
             </a:fld>
             <a:endParaRPr lang="en-US"/>
           </a:p>
@@ -767,7 +769,7 @@
           <a:p>
             <a:fld id="{F2DEBFF9-250A-4D6B-B7B3-3F1E7C2640FE}" type="datetimeFigureOut">
               <a:rPr lang="en-US" smtClean="0"/>
-              <a:t>5/7/2024</a:t>
+              <a:t>5/21/2024</a:t>
             </a:fld>
             <a:endParaRPr lang="en-US"/>
           </a:p>
@@ -1011,7 +1013,7 @@
           <a:p>
             <a:fld id="{F2DEBFF9-250A-4D6B-B7B3-3F1E7C2640FE}" type="datetimeFigureOut">
               <a:rPr lang="en-US" smtClean="0"/>
-              <a:t>5/7/2024</a:t>
+              <a:t>5/21/2024</a:t>
             </a:fld>
             <a:endParaRPr lang="en-US"/>
           </a:p>
@@ -1243,7 +1245,7 @@
           <a:p>
             <a:fld id="{F2DEBFF9-250A-4D6B-B7B3-3F1E7C2640FE}" type="datetimeFigureOut">
               <a:rPr lang="en-US" smtClean="0"/>
-              <a:t>5/7/2024</a:t>
+              <a:t>5/21/2024</a:t>
             </a:fld>
             <a:endParaRPr lang="en-US"/>
           </a:p>
@@ -1610,7 +1612,7 @@
           <a:p>
             <a:fld id="{F2DEBFF9-250A-4D6B-B7B3-3F1E7C2640FE}" type="datetimeFigureOut">
               <a:rPr lang="en-US" smtClean="0"/>
-              <a:t>5/7/2024</a:t>
+              <a:t>5/21/2024</a:t>
             </a:fld>
             <a:endParaRPr lang="en-US"/>
           </a:p>
@@ -1728,7 +1730,7 @@
           <a:p>
             <a:fld id="{F2DEBFF9-250A-4D6B-B7B3-3F1E7C2640FE}" type="datetimeFigureOut">
               <a:rPr lang="en-US" smtClean="0"/>
-              <a:t>5/7/2024</a:t>
+              <a:t>5/21/2024</a:t>
             </a:fld>
             <a:endParaRPr lang="en-US"/>
           </a:p>
@@ -1823,7 +1825,7 @@
           <a:p>
             <a:fld id="{F2DEBFF9-250A-4D6B-B7B3-3F1E7C2640FE}" type="datetimeFigureOut">
               <a:rPr lang="en-US" smtClean="0"/>
-              <a:t>5/7/2024</a:t>
+              <a:t>5/21/2024</a:t>
             </a:fld>
             <a:endParaRPr lang="en-US"/>
           </a:p>
@@ -2100,7 +2102,7 @@
           <a:p>
             <a:fld id="{F2DEBFF9-250A-4D6B-B7B3-3F1E7C2640FE}" type="datetimeFigureOut">
               <a:rPr lang="en-US" smtClean="0"/>
-              <a:t>5/7/2024</a:t>
+              <a:t>5/21/2024</a:t>
             </a:fld>
             <a:endParaRPr lang="en-US"/>
           </a:p>
@@ -2357,7 +2359,7 @@
           <a:p>
             <a:fld id="{F2DEBFF9-250A-4D6B-B7B3-3F1E7C2640FE}" type="datetimeFigureOut">
               <a:rPr lang="en-US" smtClean="0"/>
-              <a:t>5/7/2024</a:t>
+              <a:t>5/21/2024</a:t>
             </a:fld>
             <a:endParaRPr lang="en-US"/>
           </a:p>
@@ -2570,7 +2572,7 @@
           <a:p>
             <a:fld id="{F2DEBFF9-250A-4D6B-B7B3-3F1E7C2640FE}" type="datetimeFigureOut">
               <a:rPr lang="en-US" smtClean="0"/>
-              <a:t>5/7/2024</a:t>
+              <a:t>5/21/2024</a:t>
             </a:fld>
             <a:endParaRPr lang="en-US"/>
           </a:p>
@@ -7548,6 +7550,4316 @@
 </p:sld>
 </file>
 
+<file path=ppt/slides/slide6.xml><?xml version="1.0" encoding="utf-8"?>
+<p:sld xmlns:a="http://schemas.openxmlformats.org/drawingml/2006/main" xmlns:r="http://schemas.openxmlformats.org/officeDocument/2006/relationships" xmlns:p="http://schemas.openxmlformats.org/presentationml/2006/main">
+  <p:cSld>
+    <p:spTree>
+      <p:nvGrpSpPr>
+        <p:cNvPr id="1" name=""/>
+        <p:cNvGrpSpPr/>
+        <p:nvPr/>
+      </p:nvGrpSpPr>
+      <p:grpSpPr>
+        <a:xfrm>
+          <a:off x="0" y="0"/>
+          <a:ext cx="0" cy="0"/>
+          <a:chOff x="0" y="0"/>
+          <a:chExt cx="0" cy="0"/>
+        </a:xfrm>
+      </p:grpSpPr>
+      <p:sp>
+        <p:nvSpPr>
+          <p:cNvPr id="2" name="Title 1">
+            <a:extLst>
+              <a:ext uri="{FF2B5EF4-FFF2-40B4-BE49-F238E27FC236}">
+                <a16:creationId xmlns:a16="http://schemas.microsoft.com/office/drawing/2014/main" id="{A57D5918-4412-F96F-6BE6-1C6F8A9CEEDC}"/>
+              </a:ext>
+            </a:extLst>
+          </p:cNvPr>
+          <p:cNvSpPr>
+            <a:spLocks noGrp="1"/>
+          </p:cNvSpPr>
+          <p:nvPr>
+            <p:ph type="title"/>
+          </p:nvPr>
+        </p:nvSpPr>
+        <p:spPr>
+          <a:xfrm>
+            <a:off x="39758" y="106056"/>
+            <a:ext cx="2703442" cy="184790"/>
+          </a:xfrm>
+        </p:spPr>
+        <p:txBody>
+          <a:bodyPr>
+            <a:normAutofit fontScale="90000"/>
+          </a:bodyPr>
+          <a:lstStyle/>
+          <a:p>
+            <a:r>
+              <a:rPr lang="en-US" dirty="0"/>
+              <a:t>App Icon Sketch for presentations (Large)</a:t>
+            </a:r>
+          </a:p>
+        </p:txBody>
+      </p:sp>
+      <p:grpSp>
+        <p:nvGrpSpPr>
+          <p:cNvPr id="3" name="Group 2">
+            <a:extLst>
+              <a:ext uri="{FF2B5EF4-FFF2-40B4-BE49-F238E27FC236}">
+                <a16:creationId xmlns:a16="http://schemas.microsoft.com/office/drawing/2014/main" id="{A5D8EF81-15A1-27A5-09BC-182AC9D98AD6}"/>
+              </a:ext>
+            </a:extLst>
+          </p:cNvPr>
+          <p:cNvGrpSpPr/>
+          <p:nvPr/>
+        </p:nvGrpSpPr>
+        <p:grpSpPr>
+          <a:xfrm>
+            <a:off x="338095" y="379809"/>
+            <a:ext cx="1994726" cy="2264824"/>
+            <a:chOff x="338095" y="379809"/>
+            <a:chExt cx="1994726" cy="2264824"/>
+          </a:xfrm>
+        </p:grpSpPr>
+        <p:sp>
+          <p:nvSpPr>
+            <p:cNvPr id="4" name="Rectangle: Rounded Corners 3">
+              <a:extLst>
+                <a:ext uri="{FF2B5EF4-FFF2-40B4-BE49-F238E27FC236}">
+                  <a16:creationId xmlns:a16="http://schemas.microsoft.com/office/drawing/2014/main" id="{907A9D7C-7957-36EE-F67A-08990A2EC149}"/>
+                </a:ext>
+              </a:extLst>
+            </p:cNvPr>
+            <p:cNvSpPr/>
+            <p:nvPr/>
+          </p:nvSpPr>
+          <p:spPr>
+            <a:xfrm>
+              <a:off x="338095" y="379809"/>
+              <a:ext cx="1994726" cy="2264824"/>
+            </a:xfrm>
+            <a:prstGeom prst="roundRect">
+              <a:avLst>
+                <a:gd name="adj" fmla="val 8003"/>
+              </a:avLst>
+            </a:prstGeom>
+            <a:noFill/>
+            <a:ln>
+              <a:solidFill>
+                <a:schemeClr val="bg1">
+                  <a:lumMod val="50000"/>
+                </a:schemeClr>
+              </a:solidFill>
+            </a:ln>
+          </p:spPr>
+          <p:style>
+            <a:lnRef idx="2">
+              <a:schemeClr val="accent1">
+                <a:shade val="50000"/>
+              </a:schemeClr>
+            </a:lnRef>
+            <a:fillRef idx="1">
+              <a:schemeClr val="accent1"/>
+            </a:fillRef>
+            <a:effectRef idx="0">
+              <a:schemeClr val="accent1"/>
+            </a:effectRef>
+            <a:fontRef idx="minor">
+              <a:schemeClr val="lt1"/>
+            </a:fontRef>
+          </p:style>
+          <p:txBody>
+            <a:bodyPr rtlCol="0" anchor="ctr"/>
+            <a:lstStyle/>
+            <a:p>
+              <a:pPr algn="ctr"/>
+              <a:endParaRPr lang="en-US" b="1" dirty="0">
+                <a:latin typeface="Arial" pitchFamily="34" charset="0"/>
+                <a:cs typeface="Arial" pitchFamily="34" charset="0"/>
+              </a:endParaRPr>
+            </a:p>
+          </p:txBody>
+        </p:sp>
+        <p:grpSp>
+          <p:nvGrpSpPr>
+            <p:cNvPr id="5" name="Group 4">
+              <a:extLst>
+                <a:ext uri="{FF2B5EF4-FFF2-40B4-BE49-F238E27FC236}">
+                  <a16:creationId xmlns:a16="http://schemas.microsoft.com/office/drawing/2014/main" id="{1611927A-0819-5242-0168-DED1FD3A8EEB}"/>
+                </a:ext>
+              </a:extLst>
+            </p:cNvPr>
+            <p:cNvGrpSpPr/>
+            <p:nvPr/>
+          </p:nvGrpSpPr>
+          <p:grpSpPr>
+            <a:xfrm>
+              <a:off x="765429" y="607918"/>
+              <a:ext cx="1123950" cy="1054173"/>
+              <a:chOff x="2255499" y="3431581"/>
+              <a:chExt cx="1123950" cy="1054173"/>
+            </a:xfrm>
+          </p:grpSpPr>
+          <p:sp>
+            <p:nvSpPr>
+              <p:cNvPr id="6" name="Rectangle: Rounded Corners 5">
+                <a:extLst>
+                  <a:ext uri="{FF2B5EF4-FFF2-40B4-BE49-F238E27FC236}">
+                    <a16:creationId xmlns:a16="http://schemas.microsoft.com/office/drawing/2014/main" id="{EC682087-5A10-5923-EDB3-F0797773C408}"/>
+                  </a:ext>
+                </a:extLst>
+              </p:cNvPr>
+              <p:cNvSpPr/>
+              <p:nvPr/>
+            </p:nvSpPr>
+            <p:spPr>
+              <a:xfrm>
+                <a:off x="2255499" y="3431581"/>
+                <a:ext cx="1123950" cy="1054173"/>
+              </a:xfrm>
+              <a:prstGeom prst="roundRect">
+                <a:avLst/>
+              </a:prstGeom>
+              <a:gradFill flip="none" rotWithShape="1">
+                <a:gsLst>
+                  <a:gs pos="75000">
+                    <a:schemeClr val="bg1"/>
+                  </a:gs>
+                  <a:gs pos="16000">
+                    <a:schemeClr val="bg1">
+                      <a:lumMod val="85000"/>
+                    </a:schemeClr>
+                  </a:gs>
+                </a:gsLst>
+                <a:lin ang="16200000" scaled="1"/>
+                <a:tileRect/>
+              </a:gradFill>
+              <a:ln>
+                <a:solidFill>
+                  <a:srgbClr val="C55A11"/>
+                </a:solidFill>
+              </a:ln>
+            </p:spPr>
+            <p:style>
+              <a:lnRef idx="2">
+                <a:schemeClr val="accent1">
+                  <a:shade val="50000"/>
+                </a:schemeClr>
+              </a:lnRef>
+              <a:fillRef idx="1">
+                <a:schemeClr val="accent1"/>
+              </a:fillRef>
+              <a:effectRef idx="0">
+                <a:schemeClr val="accent1"/>
+              </a:effectRef>
+              <a:fontRef idx="minor">
+                <a:schemeClr val="lt1"/>
+              </a:fontRef>
+            </p:style>
+            <p:txBody>
+              <a:bodyPr rtlCol="0" anchor="ctr"/>
+              <a:lstStyle/>
+              <a:p>
+                <a:pPr algn="ctr"/>
+                <a:endParaRPr lang="en-US" b="1" dirty="0">
+                  <a:latin typeface="Arial" pitchFamily="34" charset="0"/>
+                  <a:cs typeface="Arial" pitchFamily="34" charset="0"/>
+                </a:endParaRPr>
+              </a:p>
+            </p:txBody>
+          </p:sp>
+          <p:cxnSp>
+            <p:nvCxnSpPr>
+              <p:cNvPr id="7" name="Straight Connector 6">
+                <a:extLst>
+                  <a:ext uri="{FF2B5EF4-FFF2-40B4-BE49-F238E27FC236}">
+                    <a16:creationId xmlns:a16="http://schemas.microsoft.com/office/drawing/2014/main" id="{4DF81A87-C074-406F-F369-3758034D5ED5}"/>
+                  </a:ext>
+                </a:extLst>
+              </p:cNvPr>
+              <p:cNvCxnSpPr>
+                <a:cxnSpLocks/>
+              </p:cNvCxnSpPr>
+              <p:nvPr/>
+            </p:nvCxnSpPr>
+            <p:spPr>
+              <a:xfrm>
+                <a:off x="2795588" y="3743482"/>
+                <a:ext cx="198098" cy="0"/>
+              </a:xfrm>
+              <a:prstGeom prst="line">
+                <a:avLst/>
+              </a:prstGeom>
+              <a:ln w="38100">
+                <a:solidFill>
+                  <a:srgbClr val="2D5B9C"/>
+                </a:solidFill>
+              </a:ln>
+            </p:spPr>
+            <p:style>
+              <a:lnRef idx="1">
+                <a:schemeClr val="accent1"/>
+              </a:lnRef>
+              <a:fillRef idx="0">
+                <a:schemeClr val="accent1"/>
+              </a:fillRef>
+              <a:effectRef idx="0">
+                <a:schemeClr val="accent1"/>
+              </a:effectRef>
+              <a:fontRef idx="minor">
+                <a:schemeClr val="tx1"/>
+              </a:fontRef>
+            </p:style>
+          </p:cxnSp>
+          <p:grpSp>
+            <p:nvGrpSpPr>
+              <p:cNvPr id="8" name="Group 7">
+                <a:extLst>
+                  <a:ext uri="{FF2B5EF4-FFF2-40B4-BE49-F238E27FC236}">
+                    <a16:creationId xmlns:a16="http://schemas.microsoft.com/office/drawing/2014/main" id="{AFC750F6-2A8E-CF19-3C3E-8613AE2F2398}"/>
+                  </a:ext>
+                </a:extLst>
+              </p:cNvPr>
+              <p:cNvGrpSpPr/>
+              <p:nvPr/>
+            </p:nvGrpSpPr>
+            <p:grpSpPr>
+              <a:xfrm>
+                <a:off x="2993686" y="3615775"/>
+                <a:ext cx="314326" cy="263814"/>
+                <a:chOff x="3676649" y="3745954"/>
+                <a:chExt cx="314326" cy="263814"/>
+              </a:xfrm>
+            </p:grpSpPr>
+            <p:sp>
+              <p:nvSpPr>
+                <p:cNvPr id="37" name="Rectangle: Rounded Corners 36">
+                  <a:extLst>
+                    <a:ext uri="{FF2B5EF4-FFF2-40B4-BE49-F238E27FC236}">
+                      <a16:creationId xmlns:a16="http://schemas.microsoft.com/office/drawing/2014/main" id="{9514A207-BF7A-046F-2287-FA32D489D875}"/>
+                    </a:ext>
+                  </a:extLst>
+                </p:cNvPr>
+                <p:cNvSpPr/>
+                <p:nvPr/>
+              </p:nvSpPr>
+              <p:spPr>
+                <a:xfrm>
+                  <a:off x="3676650" y="3745954"/>
+                  <a:ext cx="314325" cy="263814"/>
+                </a:xfrm>
+                <a:prstGeom prst="roundRect">
+                  <a:avLst>
+                    <a:gd name="adj" fmla="val 9455"/>
+                  </a:avLst>
+                </a:prstGeom>
+                <a:solidFill>
+                  <a:schemeClr val="bg1"/>
+                </a:solidFill>
+                <a:ln>
+                  <a:solidFill>
+                    <a:srgbClr val="265598"/>
+                  </a:solidFill>
+                </a:ln>
+              </p:spPr>
+              <p:style>
+                <a:lnRef idx="2">
+                  <a:schemeClr val="accent1">
+                    <a:shade val="50000"/>
+                  </a:schemeClr>
+                </a:lnRef>
+                <a:fillRef idx="1">
+                  <a:schemeClr val="accent1"/>
+                </a:fillRef>
+                <a:effectRef idx="0">
+                  <a:schemeClr val="accent1"/>
+                </a:effectRef>
+                <a:fontRef idx="minor">
+                  <a:schemeClr val="lt1"/>
+                </a:fontRef>
+              </p:style>
+              <p:txBody>
+                <a:bodyPr rtlCol="0" anchor="ctr"/>
+                <a:lstStyle/>
+                <a:p>
+                  <a:pPr algn="ctr"/>
+                  <a:endParaRPr lang="en-US" b="1" dirty="0">
+                    <a:latin typeface="Arial" pitchFamily="34" charset="0"/>
+                    <a:cs typeface="Arial" pitchFamily="34" charset="0"/>
+                  </a:endParaRPr>
+                </a:p>
+              </p:txBody>
+            </p:sp>
+            <p:sp>
+              <p:nvSpPr>
+                <p:cNvPr id="38" name="Freeform: Shape 37">
+                  <a:extLst>
+                    <a:ext uri="{FF2B5EF4-FFF2-40B4-BE49-F238E27FC236}">
+                      <a16:creationId xmlns:a16="http://schemas.microsoft.com/office/drawing/2014/main" id="{BE1A9E64-DA74-DF74-D252-4687B856A2D2}"/>
+                    </a:ext>
+                  </a:extLst>
+                </p:cNvPr>
+                <p:cNvSpPr/>
+                <p:nvPr/>
+              </p:nvSpPr>
+              <p:spPr>
+                <a:xfrm>
+                  <a:off x="3676649" y="3745955"/>
+                  <a:ext cx="314325" cy="88475"/>
+                </a:xfrm>
+                <a:custGeom>
+                  <a:avLst/>
+                  <a:gdLst>
+                    <a:gd name="connsiteX0" fmla="*/ 31220 w 409575"/>
+                    <a:gd name="connsiteY0" fmla="*/ 0 h 88475"/>
+                    <a:gd name="connsiteX1" fmla="*/ 378355 w 409575"/>
+                    <a:gd name="connsiteY1" fmla="*/ 0 h 88475"/>
+                    <a:gd name="connsiteX2" fmla="*/ 409575 w 409575"/>
+                    <a:gd name="connsiteY2" fmla="*/ 31220 h 88475"/>
+                    <a:gd name="connsiteX3" fmla="*/ 409575 w 409575"/>
+                    <a:gd name="connsiteY3" fmla="*/ 88475 h 88475"/>
+                    <a:gd name="connsiteX4" fmla="*/ 0 w 409575"/>
+                    <a:gd name="connsiteY4" fmla="*/ 88475 h 88475"/>
+                    <a:gd name="connsiteX5" fmla="*/ 0 w 409575"/>
+                    <a:gd name="connsiteY5" fmla="*/ 31220 h 88475"/>
+                    <a:gd name="connsiteX6" fmla="*/ 31220 w 409575"/>
+                    <a:gd name="connsiteY6" fmla="*/ 0 h 88475"/>
+                  </a:gdLst>
+                  <a:ahLst/>
+                  <a:cxnLst>
+                    <a:cxn ang="0">
+                      <a:pos x="connsiteX0" y="connsiteY0"/>
+                    </a:cxn>
+                    <a:cxn ang="0">
+                      <a:pos x="connsiteX1" y="connsiteY1"/>
+                    </a:cxn>
+                    <a:cxn ang="0">
+                      <a:pos x="connsiteX2" y="connsiteY2"/>
+                    </a:cxn>
+                    <a:cxn ang="0">
+                      <a:pos x="connsiteX3" y="connsiteY3"/>
+                    </a:cxn>
+                    <a:cxn ang="0">
+                      <a:pos x="connsiteX4" y="connsiteY4"/>
+                    </a:cxn>
+                    <a:cxn ang="0">
+                      <a:pos x="connsiteX5" y="connsiteY5"/>
+                    </a:cxn>
+                    <a:cxn ang="0">
+                      <a:pos x="connsiteX6" y="connsiteY6"/>
+                    </a:cxn>
+                  </a:cxnLst>
+                  <a:rect l="l" t="t" r="r" b="b"/>
+                  <a:pathLst>
+                    <a:path w="409575" h="88475">
+                      <a:moveTo>
+                        <a:pt x="31220" y="0"/>
+                      </a:moveTo>
+                      <a:lnTo>
+                        <a:pt x="378355" y="0"/>
+                      </a:lnTo>
+                      <a:cubicBezTo>
+                        <a:pt x="395597" y="0"/>
+                        <a:pt x="409575" y="13978"/>
+                        <a:pt x="409575" y="31220"/>
+                      </a:cubicBezTo>
+                      <a:lnTo>
+                        <a:pt x="409575" y="88475"/>
+                      </a:lnTo>
+                      <a:lnTo>
+                        <a:pt x="0" y="88475"/>
+                      </a:lnTo>
+                      <a:lnTo>
+                        <a:pt x="0" y="31220"/>
+                      </a:lnTo>
+                      <a:cubicBezTo>
+                        <a:pt x="0" y="13978"/>
+                        <a:pt x="13978" y="0"/>
+                        <a:pt x="31220" y="0"/>
+                      </a:cubicBezTo>
+                      <a:close/>
+                    </a:path>
+                  </a:pathLst>
+                </a:custGeom>
+                <a:solidFill>
+                  <a:srgbClr val="C0CAD9"/>
+                </a:solidFill>
+                <a:ln>
+                  <a:solidFill>
+                    <a:srgbClr val="265598"/>
+                  </a:solidFill>
+                </a:ln>
+              </p:spPr>
+              <p:style>
+                <a:lnRef idx="2">
+                  <a:schemeClr val="accent1">
+                    <a:shade val="50000"/>
+                  </a:schemeClr>
+                </a:lnRef>
+                <a:fillRef idx="1">
+                  <a:schemeClr val="accent1"/>
+                </a:fillRef>
+                <a:effectRef idx="0">
+                  <a:schemeClr val="accent1"/>
+                </a:effectRef>
+                <a:fontRef idx="minor">
+                  <a:schemeClr val="lt1"/>
+                </a:fontRef>
+              </p:style>
+              <p:txBody>
+                <a:bodyPr wrap="square" rtlCol="0" anchor="ctr">
+                  <a:noAutofit/>
+                </a:bodyPr>
+                <a:lstStyle/>
+                <a:p>
+                  <a:pPr algn="ctr"/>
+                  <a:endParaRPr lang="en-US" b="1" dirty="0">
+                    <a:latin typeface="Arial" pitchFamily="34" charset="0"/>
+                    <a:cs typeface="Arial" pitchFamily="34" charset="0"/>
+                  </a:endParaRPr>
+                </a:p>
+              </p:txBody>
+            </p:sp>
+          </p:grpSp>
+          <p:cxnSp>
+            <p:nvCxnSpPr>
+              <p:cNvPr id="9" name="Connector: Elbow 8">
+                <a:extLst>
+                  <a:ext uri="{FF2B5EF4-FFF2-40B4-BE49-F238E27FC236}">
+                    <a16:creationId xmlns:a16="http://schemas.microsoft.com/office/drawing/2014/main" id="{A899AD7F-2D0D-7400-4FF9-24CF444D112C}"/>
+                  </a:ext>
+                </a:extLst>
+              </p:cNvPr>
+              <p:cNvCxnSpPr>
+                <a:cxnSpLocks/>
+                <a:stCxn id="13" idx="2"/>
+                <a:endCxn id="12" idx="0"/>
+              </p:cNvCxnSpPr>
+              <p:nvPr/>
+            </p:nvCxnSpPr>
+            <p:spPr>
+              <a:xfrm rot="5400000">
+                <a:off x="2370526" y="3929137"/>
+                <a:ext cx="313852" cy="164887"/>
+              </a:xfrm>
+              <a:prstGeom prst="bentConnector3">
+                <a:avLst>
+                  <a:gd name="adj1" fmla="val 50000"/>
+                </a:avLst>
+              </a:prstGeom>
+              <a:ln w="38100">
+                <a:solidFill>
+                  <a:srgbClr val="4E4F4E"/>
+                </a:solidFill>
+              </a:ln>
+            </p:spPr>
+            <p:style>
+              <a:lnRef idx="1">
+                <a:schemeClr val="accent1"/>
+              </a:lnRef>
+              <a:fillRef idx="0">
+                <a:schemeClr val="accent1"/>
+              </a:fillRef>
+              <a:effectRef idx="0">
+                <a:schemeClr val="accent1"/>
+              </a:effectRef>
+              <a:fontRef idx="minor">
+                <a:schemeClr val="tx1"/>
+              </a:fontRef>
+            </p:style>
+          </p:cxnSp>
+          <p:cxnSp>
+            <p:nvCxnSpPr>
+              <p:cNvPr id="10" name="Connector: Elbow 9">
+                <a:extLst>
+                  <a:ext uri="{FF2B5EF4-FFF2-40B4-BE49-F238E27FC236}">
+                    <a16:creationId xmlns:a16="http://schemas.microsoft.com/office/drawing/2014/main" id="{17E2EDE3-0760-A40E-95D8-6956AED19256}"/>
+                  </a:ext>
+                </a:extLst>
+              </p:cNvPr>
+              <p:cNvCxnSpPr>
+                <a:cxnSpLocks/>
+                <a:stCxn id="13" idx="2"/>
+                <a:endCxn id="11" idx="0"/>
+              </p:cNvCxnSpPr>
+              <p:nvPr/>
+            </p:nvCxnSpPr>
+            <p:spPr>
+              <a:xfrm rot="16200000" flipH="1">
+                <a:off x="2527171" y="3937377"/>
+                <a:ext cx="308437" cy="142989"/>
+              </a:xfrm>
+              <a:prstGeom prst="bentConnector3">
+                <a:avLst>
+                  <a:gd name="adj1" fmla="val 50772"/>
+                </a:avLst>
+              </a:prstGeom>
+              <a:ln w="38100">
+                <a:solidFill>
+                  <a:srgbClr val="4E4F4E"/>
+                </a:solidFill>
+              </a:ln>
+            </p:spPr>
+            <p:style>
+              <a:lnRef idx="1">
+                <a:schemeClr val="accent1"/>
+              </a:lnRef>
+              <a:fillRef idx="0">
+                <a:schemeClr val="accent1"/>
+              </a:fillRef>
+              <a:effectRef idx="0">
+                <a:schemeClr val="accent1"/>
+              </a:effectRef>
+              <a:fontRef idx="minor">
+                <a:schemeClr val="tx1"/>
+              </a:fontRef>
+            </p:style>
+          </p:cxnSp>
+          <p:sp>
+            <p:nvSpPr>
+              <p:cNvPr id="11" name="Rectangle 10">
+                <a:extLst>
+                  <a:ext uri="{FF2B5EF4-FFF2-40B4-BE49-F238E27FC236}">
+                    <a16:creationId xmlns:a16="http://schemas.microsoft.com/office/drawing/2014/main" id="{4B405FD8-34CF-0506-19B1-ECC339447786}"/>
+                  </a:ext>
+                </a:extLst>
+              </p:cNvPr>
+              <p:cNvSpPr/>
+              <p:nvPr/>
+            </p:nvSpPr>
+            <p:spPr>
+              <a:xfrm>
+                <a:off x="2634516" y="4163091"/>
+                <a:ext cx="236735" cy="197686"/>
+              </a:xfrm>
+              <a:prstGeom prst="rect">
+                <a:avLst/>
+              </a:prstGeom>
+              <a:gradFill flip="none" rotWithShape="1">
+                <a:gsLst>
+                  <a:gs pos="0">
+                    <a:srgbClr val="FFD752">
+                      <a:shade val="30000"/>
+                      <a:satMod val="115000"/>
+                    </a:srgbClr>
+                  </a:gs>
+                  <a:gs pos="27000">
+                    <a:srgbClr val="FFD752">
+                      <a:shade val="67500"/>
+                      <a:satMod val="115000"/>
+                    </a:srgbClr>
+                  </a:gs>
+                  <a:gs pos="100000">
+                    <a:schemeClr val="bg1">
+                      <a:lumMod val="95000"/>
+                    </a:schemeClr>
+                  </a:gs>
+                  <a:gs pos="60000">
+                    <a:srgbClr val="FFD752">
+                      <a:shade val="100000"/>
+                      <a:satMod val="115000"/>
+                    </a:srgbClr>
+                  </a:gs>
+                </a:gsLst>
+                <a:lin ang="16200000" scaled="1"/>
+                <a:tileRect/>
+              </a:gradFill>
+              <a:ln>
+                <a:solidFill>
+                  <a:srgbClr val="76622B"/>
+                </a:solidFill>
+              </a:ln>
+            </p:spPr>
+            <p:style>
+              <a:lnRef idx="2">
+                <a:schemeClr val="accent1">
+                  <a:shade val="50000"/>
+                </a:schemeClr>
+              </a:lnRef>
+              <a:fillRef idx="1">
+                <a:schemeClr val="accent1"/>
+              </a:fillRef>
+              <a:effectRef idx="0">
+                <a:schemeClr val="accent1"/>
+              </a:effectRef>
+              <a:fontRef idx="minor">
+                <a:schemeClr val="lt1"/>
+              </a:fontRef>
+            </p:style>
+            <p:txBody>
+              <a:bodyPr rtlCol="0" anchor="ctr"/>
+              <a:lstStyle/>
+              <a:p>
+                <a:pPr algn="ctr"/>
+                <a:endParaRPr lang="en-US" b="1" dirty="0">
+                  <a:latin typeface="Arial" pitchFamily="34" charset="0"/>
+                  <a:cs typeface="Arial" pitchFamily="34" charset="0"/>
+                </a:endParaRPr>
+              </a:p>
+            </p:txBody>
+          </p:sp>
+          <p:sp>
+            <p:nvSpPr>
+              <p:cNvPr id="12" name="Rectangle 11">
+                <a:extLst>
+                  <a:ext uri="{FF2B5EF4-FFF2-40B4-BE49-F238E27FC236}">
+                    <a16:creationId xmlns:a16="http://schemas.microsoft.com/office/drawing/2014/main" id="{B4D4D5BA-9BD0-5133-2160-8D146CA55F26}"/>
+                  </a:ext>
+                </a:extLst>
+              </p:cNvPr>
+              <p:cNvSpPr/>
+              <p:nvPr/>
+            </p:nvSpPr>
+            <p:spPr>
+              <a:xfrm>
+                <a:off x="2326640" y="4168506"/>
+                <a:ext cx="236735" cy="197686"/>
+              </a:xfrm>
+              <a:prstGeom prst="rect">
+                <a:avLst/>
+              </a:prstGeom>
+              <a:gradFill flip="none" rotWithShape="1">
+                <a:gsLst>
+                  <a:gs pos="0">
+                    <a:srgbClr val="FFD752">
+                      <a:shade val="30000"/>
+                      <a:satMod val="115000"/>
+                    </a:srgbClr>
+                  </a:gs>
+                  <a:gs pos="27000">
+                    <a:srgbClr val="FFD752">
+                      <a:shade val="67500"/>
+                      <a:satMod val="115000"/>
+                    </a:srgbClr>
+                  </a:gs>
+                  <a:gs pos="100000">
+                    <a:schemeClr val="bg1">
+                      <a:lumMod val="95000"/>
+                    </a:schemeClr>
+                  </a:gs>
+                  <a:gs pos="60000">
+                    <a:srgbClr val="FFD752">
+                      <a:shade val="100000"/>
+                      <a:satMod val="115000"/>
+                    </a:srgbClr>
+                  </a:gs>
+                </a:gsLst>
+                <a:lin ang="16200000" scaled="1"/>
+                <a:tileRect/>
+              </a:gradFill>
+              <a:ln>
+                <a:solidFill>
+                  <a:srgbClr val="76622B"/>
+                </a:solidFill>
+              </a:ln>
+            </p:spPr>
+            <p:style>
+              <a:lnRef idx="2">
+                <a:schemeClr val="accent1">
+                  <a:shade val="50000"/>
+                </a:schemeClr>
+              </a:lnRef>
+              <a:fillRef idx="1">
+                <a:schemeClr val="accent1"/>
+              </a:fillRef>
+              <a:effectRef idx="0">
+                <a:schemeClr val="accent1"/>
+              </a:effectRef>
+              <a:fontRef idx="minor">
+                <a:schemeClr val="lt1"/>
+              </a:fontRef>
+            </p:style>
+            <p:txBody>
+              <a:bodyPr rtlCol="0" anchor="ctr"/>
+              <a:lstStyle/>
+              <a:p>
+                <a:pPr algn="ctr"/>
+                <a:endParaRPr lang="en-US" b="1" dirty="0">
+                  <a:latin typeface="Arial" pitchFamily="34" charset="0"/>
+                  <a:cs typeface="Arial" pitchFamily="34" charset="0"/>
+                </a:endParaRPr>
+              </a:p>
+            </p:txBody>
+          </p:sp>
+          <p:sp>
+            <p:nvSpPr>
+              <p:cNvPr id="13" name="Rectangle 12">
+                <a:extLst>
+                  <a:ext uri="{FF2B5EF4-FFF2-40B4-BE49-F238E27FC236}">
+                    <a16:creationId xmlns:a16="http://schemas.microsoft.com/office/drawing/2014/main" id="{A6D21BD8-C9E2-DCA0-32AB-6C3DFA4C6980}"/>
+                  </a:ext>
+                </a:extLst>
+              </p:cNvPr>
+              <p:cNvSpPr/>
+              <p:nvPr/>
+            </p:nvSpPr>
+            <p:spPr>
+              <a:xfrm>
+                <a:off x="2476725" y="3656967"/>
+                <a:ext cx="266339" cy="197687"/>
+              </a:xfrm>
+              <a:prstGeom prst="rect">
+                <a:avLst/>
+              </a:prstGeom>
+              <a:gradFill flip="none" rotWithShape="1">
+                <a:gsLst>
+                  <a:gs pos="0">
+                    <a:srgbClr val="FFD752">
+                      <a:shade val="30000"/>
+                      <a:satMod val="115000"/>
+                    </a:srgbClr>
+                  </a:gs>
+                  <a:gs pos="27000">
+                    <a:srgbClr val="FFD752">
+                      <a:shade val="67500"/>
+                      <a:satMod val="115000"/>
+                    </a:srgbClr>
+                  </a:gs>
+                  <a:gs pos="100000">
+                    <a:schemeClr val="bg1">
+                      <a:lumMod val="95000"/>
+                    </a:schemeClr>
+                  </a:gs>
+                  <a:gs pos="60000">
+                    <a:srgbClr val="FFD752">
+                      <a:shade val="100000"/>
+                      <a:satMod val="115000"/>
+                    </a:srgbClr>
+                  </a:gs>
+                </a:gsLst>
+                <a:lin ang="16200000" scaled="1"/>
+                <a:tileRect/>
+              </a:gradFill>
+              <a:ln>
+                <a:solidFill>
+                  <a:srgbClr val="76622B"/>
+                </a:solidFill>
+              </a:ln>
+            </p:spPr>
+            <p:style>
+              <a:lnRef idx="2">
+                <a:schemeClr val="accent1">
+                  <a:shade val="50000"/>
+                </a:schemeClr>
+              </a:lnRef>
+              <a:fillRef idx="1">
+                <a:schemeClr val="accent1"/>
+              </a:fillRef>
+              <a:effectRef idx="0">
+                <a:schemeClr val="accent1"/>
+              </a:effectRef>
+              <a:fontRef idx="minor">
+                <a:schemeClr val="lt1"/>
+              </a:fontRef>
+            </p:style>
+            <p:txBody>
+              <a:bodyPr rtlCol="0" anchor="ctr"/>
+              <a:lstStyle/>
+              <a:p>
+                <a:pPr algn="ctr"/>
+                <a:endParaRPr lang="en-US" b="1" dirty="0">
+                  <a:latin typeface="Arial" pitchFamily="34" charset="0"/>
+                  <a:cs typeface="Arial" pitchFamily="34" charset="0"/>
+                </a:endParaRPr>
+              </a:p>
+            </p:txBody>
+          </p:sp>
+          <p:cxnSp>
+            <p:nvCxnSpPr>
+              <p:cNvPr id="14" name="Connector: Elbow 13">
+                <a:extLst>
+                  <a:ext uri="{FF2B5EF4-FFF2-40B4-BE49-F238E27FC236}">
+                    <a16:creationId xmlns:a16="http://schemas.microsoft.com/office/drawing/2014/main" id="{F99A8791-04FB-458E-8852-95A828D0D516}"/>
+                  </a:ext>
+                </a:extLst>
+              </p:cNvPr>
+              <p:cNvCxnSpPr>
+                <a:cxnSpLocks/>
+              </p:cNvCxnSpPr>
+              <p:nvPr/>
+            </p:nvCxnSpPr>
+            <p:spPr>
+              <a:xfrm rot="16200000" flipH="1">
+                <a:off x="2794384" y="3786082"/>
+                <a:ext cx="267834" cy="226246"/>
+              </a:xfrm>
+              <a:prstGeom prst="bentConnector3">
+                <a:avLst>
+                  <a:gd name="adj1" fmla="val 129128"/>
+                </a:avLst>
+              </a:prstGeom>
+              <a:ln w="38100">
+                <a:solidFill>
+                  <a:srgbClr val="2D5B9C"/>
+                </a:solidFill>
+              </a:ln>
+            </p:spPr>
+            <p:style>
+              <a:lnRef idx="1">
+                <a:schemeClr val="accent1"/>
+              </a:lnRef>
+              <a:fillRef idx="0">
+                <a:schemeClr val="accent1"/>
+              </a:fillRef>
+              <a:effectRef idx="0">
+                <a:schemeClr val="accent1"/>
+              </a:effectRef>
+              <a:fontRef idx="minor">
+                <a:schemeClr val="tx1"/>
+              </a:fontRef>
+            </p:style>
+          </p:cxnSp>
+          <p:grpSp>
+            <p:nvGrpSpPr>
+              <p:cNvPr id="15" name="Group 14">
+                <a:extLst>
+                  <a:ext uri="{FF2B5EF4-FFF2-40B4-BE49-F238E27FC236}">
+                    <a16:creationId xmlns:a16="http://schemas.microsoft.com/office/drawing/2014/main" id="{EC7E98AA-1EDD-4F69-A11C-F7EEB01231D1}"/>
+                  </a:ext>
+                </a:extLst>
+              </p:cNvPr>
+              <p:cNvGrpSpPr/>
+              <p:nvPr/>
+            </p:nvGrpSpPr>
+            <p:grpSpPr>
+              <a:xfrm>
+                <a:off x="2986475" y="3995897"/>
+                <a:ext cx="314326" cy="263814"/>
+                <a:chOff x="3676650" y="4097710"/>
+                <a:chExt cx="314326" cy="263814"/>
+              </a:xfrm>
+            </p:grpSpPr>
+            <p:sp>
+              <p:nvSpPr>
+                <p:cNvPr id="19" name="Rectangle: Rounded Corners 18">
+                  <a:extLst>
+                    <a:ext uri="{FF2B5EF4-FFF2-40B4-BE49-F238E27FC236}">
+                      <a16:creationId xmlns:a16="http://schemas.microsoft.com/office/drawing/2014/main" id="{879121BA-AD34-E551-3E15-C17535C61AF5}"/>
+                    </a:ext>
+                  </a:extLst>
+                </p:cNvPr>
+                <p:cNvSpPr/>
+                <p:nvPr/>
+              </p:nvSpPr>
+              <p:spPr>
+                <a:xfrm>
+                  <a:off x="3676651" y="4097710"/>
+                  <a:ext cx="314325" cy="263814"/>
+                </a:xfrm>
+                <a:prstGeom prst="roundRect">
+                  <a:avLst>
+                    <a:gd name="adj" fmla="val 9455"/>
+                  </a:avLst>
+                </a:prstGeom>
+                <a:solidFill>
+                  <a:schemeClr val="bg1"/>
+                </a:solidFill>
+                <a:ln>
+                  <a:solidFill>
+                    <a:srgbClr val="265598"/>
+                  </a:solidFill>
+                </a:ln>
+              </p:spPr>
+              <p:style>
+                <a:lnRef idx="2">
+                  <a:schemeClr val="accent1">
+                    <a:shade val="50000"/>
+                  </a:schemeClr>
+                </a:lnRef>
+                <a:fillRef idx="1">
+                  <a:schemeClr val="accent1"/>
+                </a:fillRef>
+                <a:effectRef idx="0">
+                  <a:schemeClr val="accent1"/>
+                </a:effectRef>
+                <a:fontRef idx="minor">
+                  <a:schemeClr val="lt1"/>
+                </a:fontRef>
+              </p:style>
+              <p:txBody>
+                <a:bodyPr rtlCol="0" anchor="ctr"/>
+                <a:lstStyle/>
+                <a:p>
+                  <a:pPr algn="ctr"/>
+                  <a:endParaRPr lang="en-US" b="1" dirty="0">
+                    <a:latin typeface="Arial" pitchFamily="34" charset="0"/>
+                    <a:cs typeface="Arial" pitchFamily="34" charset="0"/>
+                  </a:endParaRPr>
+                </a:p>
+              </p:txBody>
+            </p:sp>
+            <p:sp>
+              <p:nvSpPr>
+                <p:cNvPr id="20" name="Freeform: Shape 19">
+                  <a:extLst>
+                    <a:ext uri="{FF2B5EF4-FFF2-40B4-BE49-F238E27FC236}">
+                      <a16:creationId xmlns:a16="http://schemas.microsoft.com/office/drawing/2014/main" id="{50DAA255-26A3-7F0E-19EA-EFF3DB652F92}"/>
+                    </a:ext>
+                  </a:extLst>
+                </p:cNvPr>
+                <p:cNvSpPr/>
+                <p:nvPr/>
+              </p:nvSpPr>
+              <p:spPr>
+                <a:xfrm>
+                  <a:off x="3676650" y="4097711"/>
+                  <a:ext cx="314325" cy="88475"/>
+                </a:xfrm>
+                <a:custGeom>
+                  <a:avLst/>
+                  <a:gdLst>
+                    <a:gd name="connsiteX0" fmla="*/ 31220 w 409575"/>
+                    <a:gd name="connsiteY0" fmla="*/ 0 h 88475"/>
+                    <a:gd name="connsiteX1" fmla="*/ 378355 w 409575"/>
+                    <a:gd name="connsiteY1" fmla="*/ 0 h 88475"/>
+                    <a:gd name="connsiteX2" fmla="*/ 409575 w 409575"/>
+                    <a:gd name="connsiteY2" fmla="*/ 31220 h 88475"/>
+                    <a:gd name="connsiteX3" fmla="*/ 409575 w 409575"/>
+                    <a:gd name="connsiteY3" fmla="*/ 88475 h 88475"/>
+                    <a:gd name="connsiteX4" fmla="*/ 0 w 409575"/>
+                    <a:gd name="connsiteY4" fmla="*/ 88475 h 88475"/>
+                    <a:gd name="connsiteX5" fmla="*/ 0 w 409575"/>
+                    <a:gd name="connsiteY5" fmla="*/ 31220 h 88475"/>
+                    <a:gd name="connsiteX6" fmla="*/ 31220 w 409575"/>
+                    <a:gd name="connsiteY6" fmla="*/ 0 h 88475"/>
+                  </a:gdLst>
+                  <a:ahLst/>
+                  <a:cxnLst>
+                    <a:cxn ang="0">
+                      <a:pos x="connsiteX0" y="connsiteY0"/>
+                    </a:cxn>
+                    <a:cxn ang="0">
+                      <a:pos x="connsiteX1" y="connsiteY1"/>
+                    </a:cxn>
+                    <a:cxn ang="0">
+                      <a:pos x="connsiteX2" y="connsiteY2"/>
+                    </a:cxn>
+                    <a:cxn ang="0">
+                      <a:pos x="connsiteX3" y="connsiteY3"/>
+                    </a:cxn>
+                    <a:cxn ang="0">
+                      <a:pos x="connsiteX4" y="connsiteY4"/>
+                    </a:cxn>
+                    <a:cxn ang="0">
+                      <a:pos x="connsiteX5" y="connsiteY5"/>
+                    </a:cxn>
+                    <a:cxn ang="0">
+                      <a:pos x="connsiteX6" y="connsiteY6"/>
+                    </a:cxn>
+                  </a:cxnLst>
+                  <a:rect l="l" t="t" r="r" b="b"/>
+                  <a:pathLst>
+                    <a:path w="409575" h="88475">
+                      <a:moveTo>
+                        <a:pt x="31220" y="0"/>
+                      </a:moveTo>
+                      <a:lnTo>
+                        <a:pt x="378355" y="0"/>
+                      </a:lnTo>
+                      <a:cubicBezTo>
+                        <a:pt x="395597" y="0"/>
+                        <a:pt x="409575" y="13978"/>
+                        <a:pt x="409575" y="31220"/>
+                      </a:cubicBezTo>
+                      <a:lnTo>
+                        <a:pt x="409575" y="88475"/>
+                      </a:lnTo>
+                      <a:lnTo>
+                        <a:pt x="0" y="88475"/>
+                      </a:lnTo>
+                      <a:lnTo>
+                        <a:pt x="0" y="31220"/>
+                      </a:lnTo>
+                      <a:cubicBezTo>
+                        <a:pt x="0" y="13978"/>
+                        <a:pt x="13978" y="0"/>
+                        <a:pt x="31220" y="0"/>
+                      </a:cubicBezTo>
+                      <a:close/>
+                    </a:path>
+                  </a:pathLst>
+                </a:custGeom>
+                <a:solidFill>
+                  <a:srgbClr val="C0CAD9"/>
+                </a:solidFill>
+                <a:ln>
+                  <a:solidFill>
+                    <a:srgbClr val="265598"/>
+                  </a:solidFill>
+                </a:ln>
+              </p:spPr>
+              <p:style>
+                <a:lnRef idx="2">
+                  <a:schemeClr val="accent1">
+                    <a:shade val="50000"/>
+                  </a:schemeClr>
+                </a:lnRef>
+                <a:fillRef idx="1">
+                  <a:schemeClr val="accent1"/>
+                </a:fillRef>
+                <a:effectRef idx="0">
+                  <a:schemeClr val="accent1"/>
+                </a:effectRef>
+                <a:fontRef idx="minor">
+                  <a:schemeClr val="lt1"/>
+                </a:fontRef>
+              </p:style>
+              <p:txBody>
+                <a:bodyPr wrap="square" rtlCol="0" anchor="ctr">
+                  <a:noAutofit/>
+                </a:bodyPr>
+                <a:lstStyle/>
+                <a:p>
+                  <a:pPr algn="ctr"/>
+                  <a:endParaRPr lang="en-US" b="1" dirty="0">
+                    <a:latin typeface="Arial" pitchFamily="34" charset="0"/>
+                    <a:cs typeface="Arial" pitchFamily="34" charset="0"/>
+                  </a:endParaRPr>
+                </a:p>
+              </p:txBody>
+            </p:sp>
+          </p:grpSp>
+          <p:grpSp>
+            <p:nvGrpSpPr>
+              <p:cNvPr id="16" name="Group 15">
+                <a:extLst>
+                  <a:ext uri="{FF2B5EF4-FFF2-40B4-BE49-F238E27FC236}">
+                    <a16:creationId xmlns:a16="http://schemas.microsoft.com/office/drawing/2014/main" id="{3506FEE6-3FF4-100D-5158-9F182BA165F0}"/>
+                  </a:ext>
+                </a:extLst>
+              </p:cNvPr>
+              <p:cNvGrpSpPr/>
+              <p:nvPr/>
+            </p:nvGrpSpPr>
+            <p:grpSpPr>
+              <a:xfrm>
+                <a:off x="2585901" y="3623903"/>
+                <a:ext cx="314326" cy="263814"/>
+                <a:chOff x="3676649" y="3745954"/>
+                <a:chExt cx="314326" cy="263814"/>
+              </a:xfrm>
+            </p:grpSpPr>
+            <p:sp>
+              <p:nvSpPr>
+                <p:cNvPr id="17" name="Rectangle: Rounded Corners 16">
+                  <a:extLst>
+                    <a:ext uri="{FF2B5EF4-FFF2-40B4-BE49-F238E27FC236}">
+                      <a16:creationId xmlns:a16="http://schemas.microsoft.com/office/drawing/2014/main" id="{CAD5D9CD-EA22-EF43-DFFA-6F4FD64F33A9}"/>
+                    </a:ext>
+                  </a:extLst>
+                </p:cNvPr>
+                <p:cNvSpPr/>
+                <p:nvPr/>
+              </p:nvSpPr>
+              <p:spPr>
+                <a:xfrm>
+                  <a:off x="3676650" y="3745954"/>
+                  <a:ext cx="314325" cy="263814"/>
+                </a:xfrm>
+                <a:prstGeom prst="roundRect">
+                  <a:avLst>
+                    <a:gd name="adj" fmla="val 9455"/>
+                  </a:avLst>
+                </a:prstGeom>
+                <a:solidFill>
+                  <a:schemeClr val="bg1"/>
+                </a:solidFill>
+                <a:ln>
+                  <a:solidFill>
+                    <a:srgbClr val="265598"/>
+                  </a:solidFill>
+                </a:ln>
+              </p:spPr>
+              <p:style>
+                <a:lnRef idx="2">
+                  <a:schemeClr val="accent1">
+                    <a:shade val="50000"/>
+                  </a:schemeClr>
+                </a:lnRef>
+                <a:fillRef idx="1">
+                  <a:schemeClr val="accent1"/>
+                </a:fillRef>
+                <a:effectRef idx="0">
+                  <a:schemeClr val="accent1"/>
+                </a:effectRef>
+                <a:fontRef idx="minor">
+                  <a:schemeClr val="lt1"/>
+                </a:fontRef>
+              </p:style>
+              <p:txBody>
+                <a:bodyPr rtlCol="0" anchor="ctr"/>
+                <a:lstStyle/>
+                <a:p>
+                  <a:pPr algn="ctr"/>
+                  <a:endParaRPr lang="en-US" b="1" dirty="0">
+                    <a:latin typeface="Arial" pitchFamily="34" charset="0"/>
+                    <a:cs typeface="Arial" pitchFamily="34" charset="0"/>
+                  </a:endParaRPr>
+                </a:p>
+              </p:txBody>
+            </p:sp>
+            <p:sp>
+              <p:nvSpPr>
+                <p:cNvPr id="18" name="Freeform: Shape 17">
+                  <a:extLst>
+                    <a:ext uri="{FF2B5EF4-FFF2-40B4-BE49-F238E27FC236}">
+                      <a16:creationId xmlns:a16="http://schemas.microsoft.com/office/drawing/2014/main" id="{D76238C9-CCA8-5781-E87A-44FC2D8D4CDD}"/>
+                    </a:ext>
+                  </a:extLst>
+                </p:cNvPr>
+                <p:cNvSpPr/>
+                <p:nvPr/>
+              </p:nvSpPr>
+              <p:spPr>
+                <a:xfrm>
+                  <a:off x="3676649" y="3745955"/>
+                  <a:ext cx="314325" cy="88475"/>
+                </a:xfrm>
+                <a:custGeom>
+                  <a:avLst/>
+                  <a:gdLst>
+                    <a:gd name="connsiteX0" fmla="*/ 31220 w 409575"/>
+                    <a:gd name="connsiteY0" fmla="*/ 0 h 88475"/>
+                    <a:gd name="connsiteX1" fmla="*/ 378355 w 409575"/>
+                    <a:gd name="connsiteY1" fmla="*/ 0 h 88475"/>
+                    <a:gd name="connsiteX2" fmla="*/ 409575 w 409575"/>
+                    <a:gd name="connsiteY2" fmla="*/ 31220 h 88475"/>
+                    <a:gd name="connsiteX3" fmla="*/ 409575 w 409575"/>
+                    <a:gd name="connsiteY3" fmla="*/ 88475 h 88475"/>
+                    <a:gd name="connsiteX4" fmla="*/ 0 w 409575"/>
+                    <a:gd name="connsiteY4" fmla="*/ 88475 h 88475"/>
+                    <a:gd name="connsiteX5" fmla="*/ 0 w 409575"/>
+                    <a:gd name="connsiteY5" fmla="*/ 31220 h 88475"/>
+                    <a:gd name="connsiteX6" fmla="*/ 31220 w 409575"/>
+                    <a:gd name="connsiteY6" fmla="*/ 0 h 88475"/>
+                  </a:gdLst>
+                  <a:ahLst/>
+                  <a:cxnLst>
+                    <a:cxn ang="0">
+                      <a:pos x="connsiteX0" y="connsiteY0"/>
+                    </a:cxn>
+                    <a:cxn ang="0">
+                      <a:pos x="connsiteX1" y="connsiteY1"/>
+                    </a:cxn>
+                    <a:cxn ang="0">
+                      <a:pos x="connsiteX2" y="connsiteY2"/>
+                    </a:cxn>
+                    <a:cxn ang="0">
+                      <a:pos x="connsiteX3" y="connsiteY3"/>
+                    </a:cxn>
+                    <a:cxn ang="0">
+                      <a:pos x="connsiteX4" y="connsiteY4"/>
+                    </a:cxn>
+                    <a:cxn ang="0">
+                      <a:pos x="connsiteX5" y="connsiteY5"/>
+                    </a:cxn>
+                    <a:cxn ang="0">
+                      <a:pos x="connsiteX6" y="connsiteY6"/>
+                    </a:cxn>
+                  </a:cxnLst>
+                  <a:rect l="l" t="t" r="r" b="b"/>
+                  <a:pathLst>
+                    <a:path w="409575" h="88475">
+                      <a:moveTo>
+                        <a:pt x="31220" y="0"/>
+                      </a:moveTo>
+                      <a:lnTo>
+                        <a:pt x="378355" y="0"/>
+                      </a:lnTo>
+                      <a:cubicBezTo>
+                        <a:pt x="395597" y="0"/>
+                        <a:pt x="409575" y="13978"/>
+                        <a:pt x="409575" y="31220"/>
+                      </a:cubicBezTo>
+                      <a:lnTo>
+                        <a:pt x="409575" y="88475"/>
+                      </a:lnTo>
+                      <a:lnTo>
+                        <a:pt x="0" y="88475"/>
+                      </a:lnTo>
+                      <a:lnTo>
+                        <a:pt x="0" y="31220"/>
+                      </a:lnTo>
+                      <a:cubicBezTo>
+                        <a:pt x="0" y="13978"/>
+                        <a:pt x="13978" y="0"/>
+                        <a:pt x="31220" y="0"/>
+                      </a:cubicBezTo>
+                      <a:close/>
+                    </a:path>
+                  </a:pathLst>
+                </a:custGeom>
+                <a:solidFill>
+                  <a:srgbClr val="C0CAD9"/>
+                </a:solidFill>
+                <a:ln>
+                  <a:solidFill>
+                    <a:srgbClr val="265598"/>
+                  </a:solidFill>
+                </a:ln>
+              </p:spPr>
+              <p:style>
+                <a:lnRef idx="2">
+                  <a:schemeClr val="accent1">
+                    <a:shade val="50000"/>
+                  </a:schemeClr>
+                </a:lnRef>
+                <a:fillRef idx="1">
+                  <a:schemeClr val="accent1"/>
+                </a:fillRef>
+                <a:effectRef idx="0">
+                  <a:schemeClr val="accent1"/>
+                </a:effectRef>
+                <a:fontRef idx="minor">
+                  <a:schemeClr val="lt1"/>
+                </a:fontRef>
+              </p:style>
+              <p:txBody>
+                <a:bodyPr wrap="square" rtlCol="0" anchor="ctr">
+                  <a:noAutofit/>
+                </a:bodyPr>
+                <a:lstStyle/>
+                <a:p>
+                  <a:pPr algn="ctr"/>
+                  <a:endParaRPr lang="en-US" b="1" dirty="0">
+                    <a:latin typeface="Arial" pitchFamily="34" charset="0"/>
+                    <a:cs typeface="Arial" pitchFamily="34" charset="0"/>
+                  </a:endParaRPr>
+                </a:p>
+              </p:txBody>
+            </p:sp>
+          </p:grpSp>
+        </p:grpSp>
+        <p:grpSp>
+          <p:nvGrpSpPr>
+            <p:cNvPr id="39" name="Group 38">
+              <a:extLst>
+                <a:ext uri="{FF2B5EF4-FFF2-40B4-BE49-F238E27FC236}">
+                  <a16:creationId xmlns:a16="http://schemas.microsoft.com/office/drawing/2014/main" id="{8FC51451-2719-4147-C61F-2D7154BE3FD8}"/>
+                </a:ext>
+              </a:extLst>
+            </p:cNvPr>
+            <p:cNvGrpSpPr/>
+            <p:nvPr/>
+          </p:nvGrpSpPr>
+          <p:grpSpPr>
+            <a:xfrm>
+              <a:off x="438618" y="1927852"/>
+              <a:ext cx="1772979" cy="564497"/>
+              <a:chOff x="2247396" y="5221833"/>
+              <a:chExt cx="1772979" cy="564497"/>
+            </a:xfrm>
+          </p:grpSpPr>
+          <p:sp>
+            <p:nvSpPr>
+              <p:cNvPr id="44" name="Rectangle: Rounded Corners 43">
+                <a:extLst>
+                  <a:ext uri="{FF2B5EF4-FFF2-40B4-BE49-F238E27FC236}">
+                    <a16:creationId xmlns:a16="http://schemas.microsoft.com/office/drawing/2014/main" id="{9DC4A99A-1148-65A3-C175-2B2F842D024F}"/>
+                  </a:ext>
+                </a:extLst>
+              </p:cNvPr>
+              <p:cNvSpPr/>
+              <p:nvPr/>
+            </p:nvSpPr>
+            <p:spPr>
+              <a:xfrm>
+                <a:off x="2296825" y="5262541"/>
+                <a:ext cx="1723550" cy="508651"/>
+              </a:xfrm>
+              <a:prstGeom prst="roundRect">
+                <a:avLst>
+                  <a:gd name="adj" fmla="val 8351"/>
+                </a:avLst>
+              </a:prstGeom>
+              <a:solidFill>
+                <a:srgbClr val="283645"/>
+              </a:solidFill>
+              <a:ln>
+                <a:noFill/>
+              </a:ln>
+            </p:spPr>
+            <p:style>
+              <a:lnRef idx="2">
+                <a:schemeClr val="accent1">
+                  <a:shade val="50000"/>
+                </a:schemeClr>
+              </a:lnRef>
+              <a:fillRef idx="1">
+                <a:schemeClr val="accent1"/>
+              </a:fillRef>
+              <a:effectRef idx="0">
+                <a:schemeClr val="accent1"/>
+              </a:effectRef>
+              <a:fontRef idx="minor">
+                <a:schemeClr val="lt1"/>
+              </a:fontRef>
+            </p:style>
+            <p:txBody>
+              <a:bodyPr rtlCol="0" anchor="ctr"/>
+              <a:lstStyle/>
+              <a:p>
+                <a:pPr algn="ctr"/>
+                <a:endParaRPr lang="en-US" b="1" dirty="0">
+                  <a:latin typeface="Arial" pitchFamily="34" charset="0"/>
+                  <a:cs typeface="Arial" pitchFamily="34" charset="0"/>
+                </a:endParaRPr>
+              </a:p>
+            </p:txBody>
+          </p:sp>
+          <p:sp>
+            <p:nvSpPr>
+              <p:cNvPr id="45" name="TextBox 44">
+                <a:extLst>
+                  <a:ext uri="{FF2B5EF4-FFF2-40B4-BE49-F238E27FC236}">
+                    <a16:creationId xmlns:a16="http://schemas.microsoft.com/office/drawing/2014/main" id="{58C5519D-2CCC-2CDA-9D9D-C8E404AAC13B}"/>
+                  </a:ext>
+                </a:extLst>
+              </p:cNvPr>
+              <p:cNvSpPr txBox="1"/>
+              <p:nvPr/>
+            </p:nvSpPr>
+            <p:spPr>
+              <a:xfrm>
+                <a:off x="2247396" y="5386220"/>
+                <a:ext cx="1723549" cy="400110"/>
+              </a:xfrm>
+              <a:prstGeom prst="rect">
+                <a:avLst/>
+              </a:prstGeom>
+              <a:noFill/>
+            </p:spPr>
+            <p:txBody>
+              <a:bodyPr wrap="none" rtlCol="0">
+                <a:spAutoFit/>
+              </a:bodyPr>
+              <a:lstStyle/>
+              <a:p>
+                <a:pPr algn="ctr"/>
+                <a:r>
+                  <a:rPr lang="en-US" sz="2000" b="1" dirty="0">
+                    <a:solidFill>
+                      <a:srgbClr val="C55A11"/>
+                    </a:solidFill>
+                    <a:latin typeface="Lucida Sans Typewriter" panose="020B0509030504030204" pitchFamily="49" charset="0"/>
+                  </a:rPr>
+                  <a:t> Connector</a:t>
+                </a:r>
+              </a:p>
+            </p:txBody>
+          </p:sp>
+          <p:sp>
+            <p:nvSpPr>
+              <p:cNvPr id="46" name="TextBox 45">
+                <a:extLst>
+                  <a:ext uri="{FF2B5EF4-FFF2-40B4-BE49-F238E27FC236}">
+                    <a16:creationId xmlns:a16="http://schemas.microsoft.com/office/drawing/2014/main" id="{87A42E9D-5E2F-D7A8-6A00-D64A01AC5AA7}"/>
+                  </a:ext>
+                </a:extLst>
+              </p:cNvPr>
+              <p:cNvSpPr txBox="1"/>
+              <p:nvPr/>
+            </p:nvSpPr>
+            <p:spPr>
+              <a:xfrm>
+                <a:off x="2352767" y="5221833"/>
+                <a:ext cx="954107" cy="400110"/>
+              </a:xfrm>
+              <a:prstGeom prst="rect">
+                <a:avLst/>
+              </a:prstGeom>
+              <a:noFill/>
+            </p:spPr>
+            <p:txBody>
+              <a:bodyPr wrap="none" rtlCol="0">
+                <a:spAutoFit/>
+              </a:bodyPr>
+              <a:lstStyle/>
+              <a:p>
+                <a:pPr algn="ctr">
+                  <a:spcAft>
+                    <a:spcPts val="1200"/>
+                  </a:spcAft>
+                </a:pPr>
+                <a:r>
+                  <a:rPr lang="en-US" sz="2000" b="1" dirty="0">
+                    <a:solidFill>
+                      <a:schemeClr val="bg1"/>
+                    </a:solidFill>
+                    <a:latin typeface="Lucida Sans Typewriter" panose="020B0509030504030204" pitchFamily="49" charset="0"/>
+                  </a:rPr>
+                  <a:t>SysML</a:t>
+                </a:r>
+              </a:p>
+            </p:txBody>
+          </p:sp>
+        </p:grpSp>
+      </p:grpSp>
+    </p:spTree>
+    <p:extLst>
+      <p:ext uri="{BB962C8B-B14F-4D97-AF65-F5344CB8AC3E}">
+        <p14:creationId xmlns:p14="http://schemas.microsoft.com/office/powerpoint/2010/main" val="2520682571"/>
+      </p:ext>
+    </p:extLst>
+  </p:cSld>
+  <p:clrMapOvr>
+    <a:masterClrMapping/>
+  </p:clrMapOvr>
+</p:sld>
+</file>
+
+<file path=ppt/slides/slide7.xml><?xml version="1.0" encoding="utf-8"?>
+<p:sld xmlns:a="http://schemas.openxmlformats.org/drawingml/2006/main" xmlns:r="http://schemas.openxmlformats.org/officeDocument/2006/relationships" xmlns:p="http://schemas.openxmlformats.org/presentationml/2006/main">
+  <p:cSld>
+    <p:spTree>
+      <p:nvGrpSpPr>
+        <p:cNvPr id="1" name=""/>
+        <p:cNvGrpSpPr/>
+        <p:nvPr/>
+      </p:nvGrpSpPr>
+      <p:grpSpPr>
+        <a:xfrm>
+          <a:off x="0" y="0"/>
+          <a:ext cx="0" cy="0"/>
+          <a:chOff x="0" y="0"/>
+          <a:chExt cx="0" cy="0"/>
+        </a:xfrm>
+      </p:grpSpPr>
+      <p:sp>
+        <p:nvSpPr>
+          <p:cNvPr id="2" name="Title 1">
+            <a:extLst>
+              <a:ext uri="{FF2B5EF4-FFF2-40B4-BE49-F238E27FC236}">
+                <a16:creationId xmlns:a16="http://schemas.microsoft.com/office/drawing/2014/main" id="{3BE2E453-0C9B-680D-C20F-4DF654102904}"/>
+              </a:ext>
+            </a:extLst>
+          </p:cNvPr>
+          <p:cNvSpPr>
+            <a:spLocks noGrp="1"/>
+          </p:cNvSpPr>
+          <p:nvPr>
+            <p:ph type="title"/>
+          </p:nvPr>
+        </p:nvSpPr>
+        <p:spPr>
+          <a:xfrm>
+            <a:off x="0" y="16096"/>
+            <a:ext cx="2366010" cy="530225"/>
+          </a:xfrm>
+        </p:spPr>
+        <p:txBody>
+          <a:bodyPr/>
+          <a:lstStyle/>
+          <a:p>
+            <a:r>
+              <a:rPr lang="en-US" dirty="0"/>
+              <a:t>App Icon for presentations (Small, Medium)</a:t>
+            </a:r>
+          </a:p>
+        </p:txBody>
+      </p:sp>
+      <p:grpSp>
+        <p:nvGrpSpPr>
+          <p:cNvPr id="4" name="Group 3">
+            <a:extLst>
+              <a:ext uri="{FF2B5EF4-FFF2-40B4-BE49-F238E27FC236}">
+                <a16:creationId xmlns:a16="http://schemas.microsoft.com/office/drawing/2014/main" id="{A3CDE8E8-FC36-800E-3DBA-6C156E88535D}"/>
+              </a:ext>
+            </a:extLst>
+          </p:cNvPr>
+          <p:cNvGrpSpPr/>
+          <p:nvPr/>
+        </p:nvGrpSpPr>
+        <p:grpSpPr>
+          <a:xfrm>
+            <a:off x="105468" y="546321"/>
+            <a:ext cx="805350" cy="914399"/>
+            <a:chOff x="2234375" y="2730528"/>
+            <a:chExt cx="1994726" cy="2264824"/>
+          </a:xfrm>
+        </p:grpSpPr>
+        <p:sp>
+          <p:nvSpPr>
+            <p:cNvPr id="5" name="Rectangle: Rounded Corners 4">
+              <a:extLst>
+                <a:ext uri="{FF2B5EF4-FFF2-40B4-BE49-F238E27FC236}">
+                  <a16:creationId xmlns:a16="http://schemas.microsoft.com/office/drawing/2014/main" id="{AF9A9DB5-CF49-CD1D-1437-6526F7A9F239}"/>
+                </a:ext>
+              </a:extLst>
+            </p:cNvPr>
+            <p:cNvSpPr/>
+            <p:nvPr/>
+          </p:nvSpPr>
+          <p:spPr>
+            <a:xfrm>
+              <a:off x="2234375" y="2730528"/>
+              <a:ext cx="1994726" cy="2264824"/>
+            </a:xfrm>
+            <a:prstGeom prst="roundRect">
+              <a:avLst>
+                <a:gd name="adj" fmla="val 8003"/>
+              </a:avLst>
+            </a:prstGeom>
+            <a:noFill/>
+            <a:ln>
+              <a:solidFill>
+                <a:schemeClr val="bg1">
+                  <a:lumMod val="50000"/>
+                </a:schemeClr>
+              </a:solidFill>
+            </a:ln>
+          </p:spPr>
+          <p:style>
+            <a:lnRef idx="2">
+              <a:schemeClr val="accent1">
+                <a:shade val="50000"/>
+              </a:schemeClr>
+            </a:lnRef>
+            <a:fillRef idx="1">
+              <a:schemeClr val="accent1"/>
+            </a:fillRef>
+            <a:effectRef idx="0">
+              <a:schemeClr val="accent1"/>
+            </a:effectRef>
+            <a:fontRef idx="minor">
+              <a:schemeClr val="lt1"/>
+            </a:fontRef>
+          </p:style>
+          <p:txBody>
+            <a:bodyPr rtlCol="0" anchor="ctr"/>
+            <a:lstStyle/>
+            <a:p>
+              <a:pPr algn="ctr"/>
+              <a:endParaRPr lang="en-US" b="1" dirty="0">
+                <a:latin typeface="Arial" pitchFamily="34" charset="0"/>
+                <a:cs typeface="Arial" pitchFamily="34" charset="0"/>
+              </a:endParaRPr>
+            </a:p>
+          </p:txBody>
+        </p:sp>
+        <p:grpSp>
+          <p:nvGrpSpPr>
+            <p:cNvPr id="6" name="Group 5">
+              <a:extLst>
+                <a:ext uri="{FF2B5EF4-FFF2-40B4-BE49-F238E27FC236}">
+                  <a16:creationId xmlns:a16="http://schemas.microsoft.com/office/drawing/2014/main" id="{F1F9B157-1415-859E-200C-22DE56073897}"/>
+                </a:ext>
+              </a:extLst>
+            </p:cNvPr>
+            <p:cNvGrpSpPr/>
+            <p:nvPr/>
+          </p:nvGrpSpPr>
+          <p:grpSpPr>
+            <a:xfrm>
+              <a:off x="2661709" y="2958637"/>
+              <a:ext cx="1123950" cy="1054173"/>
+              <a:chOff x="2255499" y="3431581"/>
+              <a:chExt cx="1123950" cy="1054173"/>
+            </a:xfrm>
+          </p:grpSpPr>
+          <p:sp>
+            <p:nvSpPr>
+              <p:cNvPr id="11" name="Rectangle: Rounded Corners 10">
+                <a:extLst>
+                  <a:ext uri="{FF2B5EF4-FFF2-40B4-BE49-F238E27FC236}">
+                    <a16:creationId xmlns:a16="http://schemas.microsoft.com/office/drawing/2014/main" id="{C423BA94-FD8D-EF7C-80BC-2213EB6850EE}"/>
+                  </a:ext>
+                </a:extLst>
+              </p:cNvPr>
+              <p:cNvSpPr/>
+              <p:nvPr/>
+            </p:nvSpPr>
+            <p:spPr>
+              <a:xfrm>
+                <a:off x="2255499" y="3431581"/>
+                <a:ext cx="1123950" cy="1054173"/>
+              </a:xfrm>
+              <a:prstGeom prst="roundRect">
+                <a:avLst/>
+              </a:prstGeom>
+              <a:gradFill flip="none" rotWithShape="1">
+                <a:gsLst>
+                  <a:gs pos="75000">
+                    <a:schemeClr val="bg1"/>
+                  </a:gs>
+                  <a:gs pos="16000">
+                    <a:schemeClr val="bg1">
+                      <a:lumMod val="85000"/>
+                    </a:schemeClr>
+                  </a:gs>
+                </a:gsLst>
+                <a:lin ang="16200000" scaled="1"/>
+                <a:tileRect/>
+              </a:gradFill>
+              <a:ln w="12700">
+                <a:solidFill>
+                  <a:srgbClr val="C55A11"/>
+                </a:solidFill>
+              </a:ln>
+            </p:spPr>
+            <p:style>
+              <a:lnRef idx="2">
+                <a:schemeClr val="accent1">
+                  <a:shade val="50000"/>
+                </a:schemeClr>
+              </a:lnRef>
+              <a:fillRef idx="1">
+                <a:schemeClr val="accent1"/>
+              </a:fillRef>
+              <a:effectRef idx="0">
+                <a:schemeClr val="accent1"/>
+              </a:effectRef>
+              <a:fontRef idx="minor">
+                <a:schemeClr val="lt1"/>
+              </a:fontRef>
+            </p:style>
+            <p:txBody>
+              <a:bodyPr rtlCol="0" anchor="ctr"/>
+              <a:lstStyle/>
+              <a:p>
+                <a:pPr algn="ctr"/>
+                <a:endParaRPr lang="en-US" b="1" dirty="0">
+                  <a:latin typeface="Arial" pitchFamily="34" charset="0"/>
+                  <a:cs typeface="Arial" pitchFamily="34" charset="0"/>
+                </a:endParaRPr>
+              </a:p>
+            </p:txBody>
+          </p:sp>
+          <p:cxnSp>
+            <p:nvCxnSpPr>
+              <p:cNvPr id="12" name="Straight Connector 11">
+                <a:extLst>
+                  <a:ext uri="{FF2B5EF4-FFF2-40B4-BE49-F238E27FC236}">
+                    <a16:creationId xmlns:a16="http://schemas.microsoft.com/office/drawing/2014/main" id="{7044EE34-5A1E-BAA4-CD6A-BE8616116D26}"/>
+                  </a:ext>
+                </a:extLst>
+              </p:cNvPr>
+              <p:cNvCxnSpPr>
+                <a:cxnSpLocks/>
+              </p:cNvCxnSpPr>
+              <p:nvPr/>
+            </p:nvCxnSpPr>
+            <p:spPr>
+              <a:xfrm>
+                <a:off x="2795588" y="3743482"/>
+                <a:ext cx="198098" cy="0"/>
+              </a:xfrm>
+              <a:prstGeom prst="line">
+                <a:avLst/>
+              </a:prstGeom>
+              <a:ln w="12700">
+                <a:solidFill>
+                  <a:srgbClr val="2D5B9C"/>
+                </a:solidFill>
+              </a:ln>
+            </p:spPr>
+            <p:style>
+              <a:lnRef idx="1">
+                <a:schemeClr val="accent1"/>
+              </a:lnRef>
+              <a:fillRef idx="0">
+                <a:schemeClr val="accent1"/>
+              </a:fillRef>
+              <a:effectRef idx="0">
+                <a:schemeClr val="accent1"/>
+              </a:effectRef>
+              <a:fontRef idx="minor">
+                <a:schemeClr val="tx1"/>
+              </a:fontRef>
+            </p:style>
+          </p:cxnSp>
+          <p:grpSp>
+            <p:nvGrpSpPr>
+              <p:cNvPr id="13" name="Group 12">
+                <a:extLst>
+                  <a:ext uri="{FF2B5EF4-FFF2-40B4-BE49-F238E27FC236}">
+                    <a16:creationId xmlns:a16="http://schemas.microsoft.com/office/drawing/2014/main" id="{A9631977-9918-2E80-A71F-BB0FD68127D5}"/>
+                  </a:ext>
+                </a:extLst>
+              </p:cNvPr>
+              <p:cNvGrpSpPr/>
+              <p:nvPr/>
+            </p:nvGrpSpPr>
+            <p:grpSpPr>
+              <a:xfrm>
+                <a:off x="2993686" y="3615775"/>
+                <a:ext cx="314326" cy="263814"/>
+                <a:chOff x="3676649" y="3745954"/>
+                <a:chExt cx="314326" cy="263814"/>
+              </a:xfrm>
+            </p:grpSpPr>
+            <p:sp>
+              <p:nvSpPr>
+                <p:cNvPr id="26" name="Rectangle: Rounded Corners 25">
+                  <a:extLst>
+                    <a:ext uri="{FF2B5EF4-FFF2-40B4-BE49-F238E27FC236}">
+                      <a16:creationId xmlns:a16="http://schemas.microsoft.com/office/drawing/2014/main" id="{D14820E5-4B89-A31D-AB78-65383859B431}"/>
+                    </a:ext>
+                  </a:extLst>
+                </p:cNvPr>
+                <p:cNvSpPr/>
+                <p:nvPr/>
+              </p:nvSpPr>
+              <p:spPr>
+                <a:xfrm>
+                  <a:off x="3676650" y="3745954"/>
+                  <a:ext cx="314325" cy="263814"/>
+                </a:xfrm>
+                <a:prstGeom prst="roundRect">
+                  <a:avLst>
+                    <a:gd name="adj" fmla="val 9455"/>
+                  </a:avLst>
+                </a:prstGeom>
+                <a:solidFill>
+                  <a:schemeClr val="bg1"/>
+                </a:solidFill>
+                <a:ln w="12700">
+                  <a:solidFill>
+                    <a:srgbClr val="265598"/>
+                  </a:solidFill>
+                </a:ln>
+              </p:spPr>
+              <p:style>
+                <a:lnRef idx="2">
+                  <a:schemeClr val="accent1">
+                    <a:shade val="50000"/>
+                  </a:schemeClr>
+                </a:lnRef>
+                <a:fillRef idx="1">
+                  <a:schemeClr val="accent1"/>
+                </a:fillRef>
+                <a:effectRef idx="0">
+                  <a:schemeClr val="accent1"/>
+                </a:effectRef>
+                <a:fontRef idx="minor">
+                  <a:schemeClr val="lt1"/>
+                </a:fontRef>
+              </p:style>
+              <p:txBody>
+                <a:bodyPr rtlCol="0" anchor="ctr"/>
+                <a:lstStyle/>
+                <a:p>
+                  <a:pPr algn="ctr"/>
+                  <a:endParaRPr lang="en-US" b="1" dirty="0">
+                    <a:latin typeface="Arial" pitchFamily="34" charset="0"/>
+                    <a:cs typeface="Arial" pitchFamily="34" charset="0"/>
+                  </a:endParaRPr>
+                </a:p>
+              </p:txBody>
+            </p:sp>
+            <p:sp>
+              <p:nvSpPr>
+                <p:cNvPr id="27" name="Freeform: Shape 26">
+                  <a:extLst>
+                    <a:ext uri="{FF2B5EF4-FFF2-40B4-BE49-F238E27FC236}">
+                      <a16:creationId xmlns:a16="http://schemas.microsoft.com/office/drawing/2014/main" id="{F0E2B6AE-40B6-E820-A268-B9FD35EBAA91}"/>
+                    </a:ext>
+                  </a:extLst>
+                </p:cNvPr>
+                <p:cNvSpPr/>
+                <p:nvPr/>
+              </p:nvSpPr>
+              <p:spPr>
+                <a:xfrm>
+                  <a:off x="3676649" y="3745955"/>
+                  <a:ext cx="314325" cy="88475"/>
+                </a:xfrm>
+                <a:custGeom>
+                  <a:avLst/>
+                  <a:gdLst>
+                    <a:gd name="connsiteX0" fmla="*/ 31220 w 409575"/>
+                    <a:gd name="connsiteY0" fmla="*/ 0 h 88475"/>
+                    <a:gd name="connsiteX1" fmla="*/ 378355 w 409575"/>
+                    <a:gd name="connsiteY1" fmla="*/ 0 h 88475"/>
+                    <a:gd name="connsiteX2" fmla="*/ 409575 w 409575"/>
+                    <a:gd name="connsiteY2" fmla="*/ 31220 h 88475"/>
+                    <a:gd name="connsiteX3" fmla="*/ 409575 w 409575"/>
+                    <a:gd name="connsiteY3" fmla="*/ 88475 h 88475"/>
+                    <a:gd name="connsiteX4" fmla="*/ 0 w 409575"/>
+                    <a:gd name="connsiteY4" fmla="*/ 88475 h 88475"/>
+                    <a:gd name="connsiteX5" fmla="*/ 0 w 409575"/>
+                    <a:gd name="connsiteY5" fmla="*/ 31220 h 88475"/>
+                    <a:gd name="connsiteX6" fmla="*/ 31220 w 409575"/>
+                    <a:gd name="connsiteY6" fmla="*/ 0 h 88475"/>
+                  </a:gdLst>
+                  <a:ahLst/>
+                  <a:cxnLst>
+                    <a:cxn ang="0">
+                      <a:pos x="connsiteX0" y="connsiteY0"/>
+                    </a:cxn>
+                    <a:cxn ang="0">
+                      <a:pos x="connsiteX1" y="connsiteY1"/>
+                    </a:cxn>
+                    <a:cxn ang="0">
+                      <a:pos x="connsiteX2" y="connsiteY2"/>
+                    </a:cxn>
+                    <a:cxn ang="0">
+                      <a:pos x="connsiteX3" y="connsiteY3"/>
+                    </a:cxn>
+                    <a:cxn ang="0">
+                      <a:pos x="connsiteX4" y="connsiteY4"/>
+                    </a:cxn>
+                    <a:cxn ang="0">
+                      <a:pos x="connsiteX5" y="connsiteY5"/>
+                    </a:cxn>
+                    <a:cxn ang="0">
+                      <a:pos x="connsiteX6" y="connsiteY6"/>
+                    </a:cxn>
+                  </a:cxnLst>
+                  <a:rect l="l" t="t" r="r" b="b"/>
+                  <a:pathLst>
+                    <a:path w="409575" h="88475">
+                      <a:moveTo>
+                        <a:pt x="31220" y="0"/>
+                      </a:moveTo>
+                      <a:lnTo>
+                        <a:pt x="378355" y="0"/>
+                      </a:lnTo>
+                      <a:cubicBezTo>
+                        <a:pt x="395597" y="0"/>
+                        <a:pt x="409575" y="13978"/>
+                        <a:pt x="409575" y="31220"/>
+                      </a:cubicBezTo>
+                      <a:lnTo>
+                        <a:pt x="409575" y="88475"/>
+                      </a:lnTo>
+                      <a:lnTo>
+                        <a:pt x="0" y="88475"/>
+                      </a:lnTo>
+                      <a:lnTo>
+                        <a:pt x="0" y="31220"/>
+                      </a:lnTo>
+                      <a:cubicBezTo>
+                        <a:pt x="0" y="13978"/>
+                        <a:pt x="13978" y="0"/>
+                        <a:pt x="31220" y="0"/>
+                      </a:cubicBezTo>
+                      <a:close/>
+                    </a:path>
+                  </a:pathLst>
+                </a:custGeom>
+                <a:solidFill>
+                  <a:srgbClr val="C0CAD9"/>
+                </a:solidFill>
+                <a:ln w="12700">
+                  <a:solidFill>
+                    <a:srgbClr val="265598"/>
+                  </a:solidFill>
+                </a:ln>
+              </p:spPr>
+              <p:style>
+                <a:lnRef idx="2">
+                  <a:schemeClr val="accent1">
+                    <a:shade val="50000"/>
+                  </a:schemeClr>
+                </a:lnRef>
+                <a:fillRef idx="1">
+                  <a:schemeClr val="accent1"/>
+                </a:fillRef>
+                <a:effectRef idx="0">
+                  <a:schemeClr val="accent1"/>
+                </a:effectRef>
+                <a:fontRef idx="minor">
+                  <a:schemeClr val="lt1"/>
+                </a:fontRef>
+              </p:style>
+              <p:txBody>
+                <a:bodyPr wrap="square" rtlCol="0" anchor="ctr">
+                  <a:noAutofit/>
+                </a:bodyPr>
+                <a:lstStyle/>
+                <a:p>
+                  <a:pPr algn="ctr"/>
+                  <a:endParaRPr lang="en-US" b="1" dirty="0">
+                    <a:latin typeface="Arial" pitchFamily="34" charset="0"/>
+                    <a:cs typeface="Arial" pitchFamily="34" charset="0"/>
+                  </a:endParaRPr>
+                </a:p>
+              </p:txBody>
+            </p:sp>
+          </p:grpSp>
+          <p:cxnSp>
+            <p:nvCxnSpPr>
+              <p:cNvPr id="14" name="Connector: Elbow 13">
+                <a:extLst>
+                  <a:ext uri="{FF2B5EF4-FFF2-40B4-BE49-F238E27FC236}">
+                    <a16:creationId xmlns:a16="http://schemas.microsoft.com/office/drawing/2014/main" id="{FC9F0039-EF21-7488-9299-D69A1169800D}"/>
+                  </a:ext>
+                </a:extLst>
+              </p:cNvPr>
+              <p:cNvCxnSpPr>
+                <a:cxnSpLocks/>
+                <a:stCxn id="18" idx="2"/>
+                <a:endCxn id="17" idx="0"/>
+              </p:cNvCxnSpPr>
+              <p:nvPr/>
+            </p:nvCxnSpPr>
+            <p:spPr>
+              <a:xfrm rot="5400000">
+                <a:off x="2370526" y="3929137"/>
+                <a:ext cx="313852" cy="164887"/>
+              </a:xfrm>
+              <a:prstGeom prst="bentConnector3">
+                <a:avLst>
+                  <a:gd name="adj1" fmla="val 50000"/>
+                </a:avLst>
+              </a:prstGeom>
+              <a:ln w="12700">
+                <a:solidFill>
+                  <a:srgbClr val="4E4F4E"/>
+                </a:solidFill>
+              </a:ln>
+            </p:spPr>
+            <p:style>
+              <a:lnRef idx="1">
+                <a:schemeClr val="accent1"/>
+              </a:lnRef>
+              <a:fillRef idx="0">
+                <a:schemeClr val="accent1"/>
+              </a:fillRef>
+              <a:effectRef idx="0">
+                <a:schemeClr val="accent1"/>
+              </a:effectRef>
+              <a:fontRef idx="minor">
+                <a:schemeClr val="tx1"/>
+              </a:fontRef>
+            </p:style>
+          </p:cxnSp>
+          <p:cxnSp>
+            <p:nvCxnSpPr>
+              <p:cNvPr id="15" name="Connector: Elbow 14">
+                <a:extLst>
+                  <a:ext uri="{FF2B5EF4-FFF2-40B4-BE49-F238E27FC236}">
+                    <a16:creationId xmlns:a16="http://schemas.microsoft.com/office/drawing/2014/main" id="{1A0FBCC3-367F-D816-98A7-A871B88E2DEF}"/>
+                  </a:ext>
+                </a:extLst>
+              </p:cNvPr>
+              <p:cNvCxnSpPr>
+                <a:cxnSpLocks/>
+                <a:stCxn id="18" idx="2"/>
+                <a:endCxn id="16" idx="0"/>
+              </p:cNvCxnSpPr>
+              <p:nvPr/>
+            </p:nvCxnSpPr>
+            <p:spPr>
+              <a:xfrm rot="16200000" flipH="1">
+                <a:off x="2527171" y="3937377"/>
+                <a:ext cx="308437" cy="142989"/>
+              </a:xfrm>
+              <a:prstGeom prst="bentConnector3">
+                <a:avLst>
+                  <a:gd name="adj1" fmla="val 50772"/>
+                </a:avLst>
+              </a:prstGeom>
+              <a:ln w="12700">
+                <a:solidFill>
+                  <a:srgbClr val="4E4F4E"/>
+                </a:solidFill>
+              </a:ln>
+            </p:spPr>
+            <p:style>
+              <a:lnRef idx="1">
+                <a:schemeClr val="accent1"/>
+              </a:lnRef>
+              <a:fillRef idx="0">
+                <a:schemeClr val="accent1"/>
+              </a:fillRef>
+              <a:effectRef idx="0">
+                <a:schemeClr val="accent1"/>
+              </a:effectRef>
+              <a:fontRef idx="minor">
+                <a:schemeClr val="tx1"/>
+              </a:fontRef>
+            </p:style>
+          </p:cxnSp>
+          <p:sp>
+            <p:nvSpPr>
+              <p:cNvPr id="16" name="Rectangle 15">
+                <a:extLst>
+                  <a:ext uri="{FF2B5EF4-FFF2-40B4-BE49-F238E27FC236}">
+                    <a16:creationId xmlns:a16="http://schemas.microsoft.com/office/drawing/2014/main" id="{80390746-EB33-DCC0-3074-83D007C3F132}"/>
+                  </a:ext>
+                </a:extLst>
+              </p:cNvPr>
+              <p:cNvSpPr/>
+              <p:nvPr/>
+            </p:nvSpPr>
+            <p:spPr>
+              <a:xfrm>
+                <a:off x="2634516" y="4163091"/>
+                <a:ext cx="236735" cy="197686"/>
+              </a:xfrm>
+              <a:prstGeom prst="rect">
+                <a:avLst/>
+              </a:prstGeom>
+              <a:gradFill flip="none" rotWithShape="1">
+                <a:gsLst>
+                  <a:gs pos="0">
+                    <a:srgbClr val="FFD752">
+                      <a:shade val="30000"/>
+                      <a:satMod val="115000"/>
+                    </a:srgbClr>
+                  </a:gs>
+                  <a:gs pos="27000">
+                    <a:srgbClr val="FFD752">
+                      <a:shade val="67500"/>
+                      <a:satMod val="115000"/>
+                    </a:srgbClr>
+                  </a:gs>
+                  <a:gs pos="100000">
+                    <a:schemeClr val="bg1">
+                      <a:lumMod val="95000"/>
+                    </a:schemeClr>
+                  </a:gs>
+                  <a:gs pos="60000">
+                    <a:srgbClr val="FFD752">
+                      <a:shade val="100000"/>
+                      <a:satMod val="115000"/>
+                    </a:srgbClr>
+                  </a:gs>
+                </a:gsLst>
+                <a:lin ang="16200000" scaled="1"/>
+                <a:tileRect/>
+              </a:gradFill>
+              <a:ln w="12700">
+                <a:solidFill>
+                  <a:srgbClr val="76622B"/>
+                </a:solidFill>
+              </a:ln>
+            </p:spPr>
+            <p:style>
+              <a:lnRef idx="2">
+                <a:schemeClr val="accent1">
+                  <a:shade val="50000"/>
+                </a:schemeClr>
+              </a:lnRef>
+              <a:fillRef idx="1">
+                <a:schemeClr val="accent1"/>
+              </a:fillRef>
+              <a:effectRef idx="0">
+                <a:schemeClr val="accent1"/>
+              </a:effectRef>
+              <a:fontRef idx="minor">
+                <a:schemeClr val="lt1"/>
+              </a:fontRef>
+            </p:style>
+            <p:txBody>
+              <a:bodyPr rtlCol="0" anchor="ctr"/>
+              <a:lstStyle/>
+              <a:p>
+                <a:pPr algn="ctr"/>
+                <a:endParaRPr lang="en-US" b="1" dirty="0">
+                  <a:latin typeface="Arial" pitchFamily="34" charset="0"/>
+                  <a:cs typeface="Arial" pitchFamily="34" charset="0"/>
+                </a:endParaRPr>
+              </a:p>
+            </p:txBody>
+          </p:sp>
+          <p:sp>
+            <p:nvSpPr>
+              <p:cNvPr id="17" name="Rectangle 16">
+                <a:extLst>
+                  <a:ext uri="{FF2B5EF4-FFF2-40B4-BE49-F238E27FC236}">
+                    <a16:creationId xmlns:a16="http://schemas.microsoft.com/office/drawing/2014/main" id="{EC7C8F5D-523B-E9F2-F21D-6D605BC54FC3}"/>
+                  </a:ext>
+                </a:extLst>
+              </p:cNvPr>
+              <p:cNvSpPr/>
+              <p:nvPr/>
+            </p:nvSpPr>
+            <p:spPr>
+              <a:xfrm>
+                <a:off x="2326640" y="4168506"/>
+                <a:ext cx="236735" cy="197686"/>
+              </a:xfrm>
+              <a:prstGeom prst="rect">
+                <a:avLst/>
+              </a:prstGeom>
+              <a:gradFill flip="none" rotWithShape="1">
+                <a:gsLst>
+                  <a:gs pos="0">
+                    <a:srgbClr val="FFD752">
+                      <a:shade val="30000"/>
+                      <a:satMod val="115000"/>
+                    </a:srgbClr>
+                  </a:gs>
+                  <a:gs pos="27000">
+                    <a:srgbClr val="FFD752">
+                      <a:shade val="67500"/>
+                      <a:satMod val="115000"/>
+                    </a:srgbClr>
+                  </a:gs>
+                  <a:gs pos="100000">
+                    <a:schemeClr val="bg1">
+                      <a:lumMod val="95000"/>
+                    </a:schemeClr>
+                  </a:gs>
+                  <a:gs pos="60000">
+                    <a:srgbClr val="FFD752">
+                      <a:shade val="100000"/>
+                      <a:satMod val="115000"/>
+                    </a:srgbClr>
+                  </a:gs>
+                </a:gsLst>
+                <a:lin ang="16200000" scaled="1"/>
+                <a:tileRect/>
+              </a:gradFill>
+              <a:ln w="12700">
+                <a:solidFill>
+                  <a:srgbClr val="76622B"/>
+                </a:solidFill>
+              </a:ln>
+            </p:spPr>
+            <p:style>
+              <a:lnRef idx="2">
+                <a:schemeClr val="accent1">
+                  <a:shade val="50000"/>
+                </a:schemeClr>
+              </a:lnRef>
+              <a:fillRef idx="1">
+                <a:schemeClr val="accent1"/>
+              </a:fillRef>
+              <a:effectRef idx="0">
+                <a:schemeClr val="accent1"/>
+              </a:effectRef>
+              <a:fontRef idx="minor">
+                <a:schemeClr val="lt1"/>
+              </a:fontRef>
+            </p:style>
+            <p:txBody>
+              <a:bodyPr rtlCol="0" anchor="ctr"/>
+              <a:lstStyle/>
+              <a:p>
+                <a:pPr algn="ctr"/>
+                <a:endParaRPr lang="en-US" b="1" dirty="0">
+                  <a:latin typeface="Arial" pitchFamily="34" charset="0"/>
+                  <a:cs typeface="Arial" pitchFamily="34" charset="0"/>
+                </a:endParaRPr>
+              </a:p>
+            </p:txBody>
+          </p:sp>
+          <p:sp>
+            <p:nvSpPr>
+              <p:cNvPr id="18" name="Rectangle 17">
+                <a:extLst>
+                  <a:ext uri="{FF2B5EF4-FFF2-40B4-BE49-F238E27FC236}">
+                    <a16:creationId xmlns:a16="http://schemas.microsoft.com/office/drawing/2014/main" id="{247BDBE1-4D20-E3AD-8A34-B45AB59DD8C1}"/>
+                  </a:ext>
+                </a:extLst>
+              </p:cNvPr>
+              <p:cNvSpPr/>
+              <p:nvPr/>
+            </p:nvSpPr>
+            <p:spPr>
+              <a:xfrm>
+                <a:off x="2476725" y="3656967"/>
+                <a:ext cx="266339" cy="197687"/>
+              </a:xfrm>
+              <a:prstGeom prst="rect">
+                <a:avLst/>
+              </a:prstGeom>
+              <a:gradFill flip="none" rotWithShape="1">
+                <a:gsLst>
+                  <a:gs pos="0">
+                    <a:srgbClr val="FFD752">
+                      <a:shade val="30000"/>
+                      <a:satMod val="115000"/>
+                    </a:srgbClr>
+                  </a:gs>
+                  <a:gs pos="27000">
+                    <a:srgbClr val="FFD752">
+                      <a:shade val="67500"/>
+                      <a:satMod val="115000"/>
+                    </a:srgbClr>
+                  </a:gs>
+                  <a:gs pos="100000">
+                    <a:schemeClr val="bg1">
+                      <a:lumMod val="95000"/>
+                    </a:schemeClr>
+                  </a:gs>
+                  <a:gs pos="60000">
+                    <a:srgbClr val="FFD752">
+                      <a:shade val="100000"/>
+                      <a:satMod val="115000"/>
+                    </a:srgbClr>
+                  </a:gs>
+                </a:gsLst>
+                <a:lin ang="16200000" scaled="1"/>
+                <a:tileRect/>
+              </a:gradFill>
+              <a:ln w="12700">
+                <a:solidFill>
+                  <a:srgbClr val="76622B"/>
+                </a:solidFill>
+              </a:ln>
+            </p:spPr>
+            <p:style>
+              <a:lnRef idx="2">
+                <a:schemeClr val="accent1">
+                  <a:shade val="50000"/>
+                </a:schemeClr>
+              </a:lnRef>
+              <a:fillRef idx="1">
+                <a:schemeClr val="accent1"/>
+              </a:fillRef>
+              <a:effectRef idx="0">
+                <a:schemeClr val="accent1"/>
+              </a:effectRef>
+              <a:fontRef idx="minor">
+                <a:schemeClr val="lt1"/>
+              </a:fontRef>
+            </p:style>
+            <p:txBody>
+              <a:bodyPr rtlCol="0" anchor="ctr"/>
+              <a:lstStyle/>
+              <a:p>
+                <a:pPr algn="ctr"/>
+                <a:endParaRPr lang="en-US" b="1" dirty="0">
+                  <a:latin typeface="Arial" pitchFamily="34" charset="0"/>
+                  <a:cs typeface="Arial" pitchFamily="34" charset="0"/>
+                </a:endParaRPr>
+              </a:p>
+            </p:txBody>
+          </p:sp>
+          <p:cxnSp>
+            <p:nvCxnSpPr>
+              <p:cNvPr id="19" name="Connector: Elbow 18">
+                <a:extLst>
+                  <a:ext uri="{FF2B5EF4-FFF2-40B4-BE49-F238E27FC236}">
+                    <a16:creationId xmlns:a16="http://schemas.microsoft.com/office/drawing/2014/main" id="{F17B23B7-0AFE-95E7-0ECA-1EF1732D0133}"/>
+                  </a:ext>
+                </a:extLst>
+              </p:cNvPr>
+              <p:cNvCxnSpPr>
+                <a:cxnSpLocks/>
+              </p:cNvCxnSpPr>
+              <p:nvPr/>
+            </p:nvCxnSpPr>
+            <p:spPr>
+              <a:xfrm rot="16200000" flipH="1">
+                <a:off x="2794384" y="3786082"/>
+                <a:ext cx="267834" cy="226246"/>
+              </a:xfrm>
+              <a:prstGeom prst="bentConnector3">
+                <a:avLst>
+                  <a:gd name="adj1" fmla="val 129128"/>
+                </a:avLst>
+              </a:prstGeom>
+              <a:ln w="12700">
+                <a:solidFill>
+                  <a:srgbClr val="2D5B9C"/>
+                </a:solidFill>
+              </a:ln>
+            </p:spPr>
+            <p:style>
+              <a:lnRef idx="1">
+                <a:schemeClr val="accent1"/>
+              </a:lnRef>
+              <a:fillRef idx="0">
+                <a:schemeClr val="accent1"/>
+              </a:fillRef>
+              <a:effectRef idx="0">
+                <a:schemeClr val="accent1"/>
+              </a:effectRef>
+              <a:fontRef idx="minor">
+                <a:schemeClr val="tx1"/>
+              </a:fontRef>
+            </p:style>
+          </p:cxnSp>
+          <p:grpSp>
+            <p:nvGrpSpPr>
+              <p:cNvPr id="20" name="Group 19">
+                <a:extLst>
+                  <a:ext uri="{FF2B5EF4-FFF2-40B4-BE49-F238E27FC236}">
+                    <a16:creationId xmlns:a16="http://schemas.microsoft.com/office/drawing/2014/main" id="{793FB4C3-8A5A-FF3C-D696-5A40C24EA9CF}"/>
+                  </a:ext>
+                </a:extLst>
+              </p:cNvPr>
+              <p:cNvGrpSpPr/>
+              <p:nvPr/>
+            </p:nvGrpSpPr>
+            <p:grpSpPr>
+              <a:xfrm>
+                <a:off x="2986475" y="3995897"/>
+                <a:ext cx="314326" cy="263814"/>
+                <a:chOff x="3676650" y="4097710"/>
+                <a:chExt cx="314326" cy="263814"/>
+              </a:xfrm>
+            </p:grpSpPr>
+            <p:sp>
+              <p:nvSpPr>
+                <p:cNvPr id="24" name="Rectangle: Rounded Corners 23">
+                  <a:extLst>
+                    <a:ext uri="{FF2B5EF4-FFF2-40B4-BE49-F238E27FC236}">
+                      <a16:creationId xmlns:a16="http://schemas.microsoft.com/office/drawing/2014/main" id="{5E8E1CD1-330E-2242-D847-9DBD34D072FC}"/>
+                    </a:ext>
+                  </a:extLst>
+                </p:cNvPr>
+                <p:cNvSpPr/>
+                <p:nvPr/>
+              </p:nvSpPr>
+              <p:spPr>
+                <a:xfrm>
+                  <a:off x="3676651" y="4097710"/>
+                  <a:ext cx="314325" cy="263814"/>
+                </a:xfrm>
+                <a:prstGeom prst="roundRect">
+                  <a:avLst>
+                    <a:gd name="adj" fmla="val 9455"/>
+                  </a:avLst>
+                </a:prstGeom>
+                <a:solidFill>
+                  <a:schemeClr val="bg1"/>
+                </a:solidFill>
+                <a:ln w="12700">
+                  <a:solidFill>
+                    <a:srgbClr val="265598"/>
+                  </a:solidFill>
+                </a:ln>
+              </p:spPr>
+              <p:style>
+                <a:lnRef idx="2">
+                  <a:schemeClr val="accent1">
+                    <a:shade val="50000"/>
+                  </a:schemeClr>
+                </a:lnRef>
+                <a:fillRef idx="1">
+                  <a:schemeClr val="accent1"/>
+                </a:fillRef>
+                <a:effectRef idx="0">
+                  <a:schemeClr val="accent1"/>
+                </a:effectRef>
+                <a:fontRef idx="minor">
+                  <a:schemeClr val="lt1"/>
+                </a:fontRef>
+              </p:style>
+              <p:txBody>
+                <a:bodyPr rtlCol="0" anchor="ctr"/>
+                <a:lstStyle/>
+                <a:p>
+                  <a:pPr algn="ctr"/>
+                  <a:endParaRPr lang="en-US" b="1" dirty="0">
+                    <a:latin typeface="Arial" pitchFamily="34" charset="0"/>
+                    <a:cs typeface="Arial" pitchFamily="34" charset="0"/>
+                  </a:endParaRPr>
+                </a:p>
+              </p:txBody>
+            </p:sp>
+            <p:sp>
+              <p:nvSpPr>
+                <p:cNvPr id="25" name="Freeform: Shape 24">
+                  <a:extLst>
+                    <a:ext uri="{FF2B5EF4-FFF2-40B4-BE49-F238E27FC236}">
+                      <a16:creationId xmlns:a16="http://schemas.microsoft.com/office/drawing/2014/main" id="{E6EF4EED-EDED-4392-11F7-B138FDC33B73}"/>
+                    </a:ext>
+                  </a:extLst>
+                </p:cNvPr>
+                <p:cNvSpPr/>
+                <p:nvPr/>
+              </p:nvSpPr>
+              <p:spPr>
+                <a:xfrm>
+                  <a:off x="3676650" y="4097711"/>
+                  <a:ext cx="314325" cy="88475"/>
+                </a:xfrm>
+                <a:custGeom>
+                  <a:avLst/>
+                  <a:gdLst>
+                    <a:gd name="connsiteX0" fmla="*/ 31220 w 409575"/>
+                    <a:gd name="connsiteY0" fmla="*/ 0 h 88475"/>
+                    <a:gd name="connsiteX1" fmla="*/ 378355 w 409575"/>
+                    <a:gd name="connsiteY1" fmla="*/ 0 h 88475"/>
+                    <a:gd name="connsiteX2" fmla="*/ 409575 w 409575"/>
+                    <a:gd name="connsiteY2" fmla="*/ 31220 h 88475"/>
+                    <a:gd name="connsiteX3" fmla="*/ 409575 w 409575"/>
+                    <a:gd name="connsiteY3" fmla="*/ 88475 h 88475"/>
+                    <a:gd name="connsiteX4" fmla="*/ 0 w 409575"/>
+                    <a:gd name="connsiteY4" fmla="*/ 88475 h 88475"/>
+                    <a:gd name="connsiteX5" fmla="*/ 0 w 409575"/>
+                    <a:gd name="connsiteY5" fmla="*/ 31220 h 88475"/>
+                    <a:gd name="connsiteX6" fmla="*/ 31220 w 409575"/>
+                    <a:gd name="connsiteY6" fmla="*/ 0 h 88475"/>
+                  </a:gdLst>
+                  <a:ahLst/>
+                  <a:cxnLst>
+                    <a:cxn ang="0">
+                      <a:pos x="connsiteX0" y="connsiteY0"/>
+                    </a:cxn>
+                    <a:cxn ang="0">
+                      <a:pos x="connsiteX1" y="connsiteY1"/>
+                    </a:cxn>
+                    <a:cxn ang="0">
+                      <a:pos x="connsiteX2" y="connsiteY2"/>
+                    </a:cxn>
+                    <a:cxn ang="0">
+                      <a:pos x="connsiteX3" y="connsiteY3"/>
+                    </a:cxn>
+                    <a:cxn ang="0">
+                      <a:pos x="connsiteX4" y="connsiteY4"/>
+                    </a:cxn>
+                    <a:cxn ang="0">
+                      <a:pos x="connsiteX5" y="connsiteY5"/>
+                    </a:cxn>
+                    <a:cxn ang="0">
+                      <a:pos x="connsiteX6" y="connsiteY6"/>
+                    </a:cxn>
+                  </a:cxnLst>
+                  <a:rect l="l" t="t" r="r" b="b"/>
+                  <a:pathLst>
+                    <a:path w="409575" h="88475">
+                      <a:moveTo>
+                        <a:pt x="31220" y="0"/>
+                      </a:moveTo>
+                      <a:lnTo>
+                        <a:pt x="378355" y="0"/>
+                      </a:lnTo>
+                      <a:cubicBezTo>
+                        <a:pt x="395597" y="0"/>
+                        <a:pt x="409575" y="13978"/>
+                        <a:pt x="409575" y="31220"/>
+                      </a:cubicBezTo>
+                      <a:lnTo>
+                        <a:pt x="409575" y="88475"/>
+                      </a:lnTo>
+                      <a:lnTo>
+                        <a:pt x="0" y="88475"/>
+                      </a:lnTo>
+                      <a:lnTo>
+                        <a:pt x="0" y="31220"/>
+                      </a:lnTo>
+                      <a:cubicBezTo>
+                        <a:pt x="0" y="13978"/>
+                        <a:pt x="13978" y="0"/>
+                        <a:pt x="31220" y="0"/>
+                      </a:cubicBezTo>
+                      <a:close/>
+                    </a:path>
+                  </a:pathLst>
+                </a:custGeom>
+                <a:solidFill>
+                  <a:srgbClr val="C0CAD9"/>
+                </a:solidFill>
+                <a:ln w="12700">
+                  <a:solidFill>
+                    <a:srgbClr val="265598"/>
+                  </a:solidFill>
+                </a:ln>
+              </p:spPr>
+              <p:style>
+                <a:lnRef idx="2">
+                  <a:schemeClr val="accent1">
+                    <a:shade val="50000"/>
+                  </a:schemeClr>
+                </a:lnRef>
+                <a:fillRef idx="1">
+                  <a:schemeClr val="accent1"/>
+                </a:fillRef>
+                <a:effectRef idx="0">
+                  <a:schemeClr val="accent1"/>
+                </a:effectRef>
+                <a:fontRef idx="minor">
+                  <a:schemeClr val="lt1"/>
+                </a:fontRef>
+              </p:style>
+              <p:txBody>
+                <a:bodyPr wrap="square" rtlCol="0" anchor="ctr">
+                  <a:noAutofit/>
+                </a:bodyPr>
+                <a:lstStyle/>
+                <a:p>
+                  <a:pPr algn="ctr"/>
+                  <a:endParaRPr lang="en-US" b="1" dirty="0">
+                    <a:latin typeface="Arial" pitchFamily="34" charset="0"/>
+                    <a:cs typeface="Arial" pitchFamily="34" charset="0"/>
+                  </a:endParaRPr>
+                </a:p>
+              </p:txBody>
+            </p:sp>
+          </p:grpSp>
+          <p:grpSp>
+            <p:nvGrpSpPr>
+              <p:cNvPr id="21" name="Group 20">
+                <a:extLst>
+                  <a:ext uri="{FF2B5EF4-FFF2-40B4-BE49-F238E27FC236}">
+                    <a16:creationId xmlns:a16="http://schemas.microsoft.com/office/drawing/2014/main" id="{40E28151-576C-BB93-AD04-0D06F341EBFF}"/>
+                  </a:ext>
+                </a:extLst>
+              </p:cNvPr>
+              <p:cNvGrpSpPr/>
+              <p:nvPr/>
+            </p:nvGrpSpPr>
+            <p:grpSpPr>
+              <a:xfrm>
+                <a:off x="2585901" y="3623903"/>
+                <a:ext cx="314326" cy="263814"/>
+                <a:chOff x="3676649" y="3745954"/>
+                <a:chExt cx="314326" cy="263814"/>
+              </a:xfrm>
+            </p:grpSpPr>
+            <p:sp>
+              <p:nvSpPr>
+                <p:cNvPr id="22" name="Rectangle: Rounded Corners 21">
+                  <a:extLst>
+                    <a:ext uri="{FF2B5EF4-FFF2-40B4-BE49-F238E27FC236}">
+                      <a16:creationId xmlns:a16="http://schemas.microsoft.com/office/drawing/2014/main" id="{E32A8A47-370B-35CB-3043-0930C0AAE4E5}"/>
+                    </a:ext>
+                  </a:extLst>
+                </p:cNvPr>
+                <p:cNvSpPr/>
+                <p:nvPr/>
+              </p:nvSpPr>
+              <p:spPr>
+                <a:xfrm>
+                  <a:off x="3676650" y="3745954"/>
+                  <a:ext cx="314325" cy="263814"/>
+                </a:xfrm>
+                <a:prstGeom prst="roundRect">
+                  <a:avLst>
+                    <a:gd name="adj" fmla="val 9455"/>
+                  </a:avLst>
+                </a:prstGeom>
+                <a:solidFill>
+                  <a:schemeClr val="bg1"/>
+                </a:solidFill>
+                <a:ln w="12700">
+                  <a:solidFill>
+                    <a:srgbClr val="265598"/>
+                  </a:solidFill>
+                </a:ln>
+              </p:spPr>
+              <p:style>
+                <a:lnRef idx="2">
+                  <a:schemeClr val="accent1">
+                    <a:shade val="50000"/>
+                  </a:schemeClr>
+                </a:lnRef>
+                <a:fillRef idx="1">
+                  <a:schemeClr val="accent1"/>
+                </a:fillRef>
+                <a:effectRef idx="0">
+                  <a:schemeClr val="accent1"/>
+                </a:effectRef>
+                <a:fontRef idx="minor">
+                  <a:schemeClr val="lt1"/>
+                </a:fontRef>
+              </p:style>
+              <p:txBody>
+                <a:bodyPr rtlCol="0" anchor="ctr"/>
+                <a:lstStyle/>
+                <a:p>
+                  <a:pPr algn="ctr"/>
+                  <a:endParaRPr lang="en-US" b="1" dirty="0">
+                    <a:latin typeface="Arial" pitchFamily="34" charset="0"/>
+                    <a:cs typeface="Arial" pitchFamily="34" charset="0"/>
+                  </a:endParaRPr>
+                </a:p>
+              </p:txBody>
+            </p:sp>
+            <p:sp>
+              <p:nvSpPr>
+                <p:cNvPr id="23" name="Freeform: Shape 22">
+                  <a:extLst>
+                    <a:ext uri="{FF2B5EF4-FFF2-40B4-BE49-F238E27FC236}">
+                      <a16:creationId xmlns:a16="http://schemas.microsoft.com/office/drawing/2014/main" id="{05F8684D-9F87-296D-F336-2A4AEA1493F0}"/>
+                    </a:ext>
+                  </a:extLst>
+                </p:cNvPr>
+                <p:cNvSpPr/>
+                <p:nvPr/>
+              </p:nvSpPr>
+              <p:spPr>
+                <a:xfrm>
+                  <a:off x="3676649" y="3745955"/>
+                  <a:ext cx="314325" cy="88475"/>
+                </a:xfrm>
+                <a:custGeom>
+                  <a:avLst/>
+                  <a:gdLst>
+                    <a:gd name="connsiteX0" fmla="*/ 31220 w 409575"/>
+                    <a:gd name="connsiteY0" fmla="*/ 0 h 88475"/>
+                    <a:gd name="connsiteX1" fmla="*/ 378355 w 409575"/>
+                    <a:gd name="connsiteY1" fmla="*/ 0 h 88475"/>
+                    <a:gd name="connsiteX2" fmla="*/ 409575 w 409575"/>
+                    <a:gd name="connsiteY2" fmla="*/ 31220 h 88475"/>
+                    <a:gd name="connsiteX3" fmla="*/ 409575 w 409575"/>
+                    <a:gd name="connsiteY3" fmla="*/ 88475 h 88475"/>
+                    <a:gd name="connsiteX4" fmla="*/ 0 w 409575"/>
+                    <a:gd name="connsiteY4" fmla="*/ 88475 h 88475"/>
+                    <a:gd name="connsiteX5" fmla="*/ 0 w 409575"/>
+                    <a:gd name="connsiteY5" fmla="*/ 31220 h 88475"/>
+                    <a:gd name="connsiteX6" fmla="*/ 31220 w 409575"/>
+                    <a:gd name="connsiteY6" fmla="*/ 0 h 88475"/>
+                  </a:gdLst>
+                  <a:ahLst/>
+                  <a:cxnLst>
+                    <a:cxn ang="0">
+                      <a:pos x="connsiteX0" y="connsiteY0"/>
+                    </a:cxn>
+                    <a:cxn ang="0">
+                      <a:pos x="connsiteX1" y="connsiteY1"/>
+                    </a:cxn>
+                    <a:cxn ang="0">
+                      <a:pos x="connsiteX2" y="connsiteY2"/>
+                    </a:cxn>
+                    <a:cxn ang="0">
+                      <a:pos x="connsiteX3" y="connsiteY3"/>
+                    </a:cxn>
+                    <a:cxn ang="0">
+                      <a:pos x="connsiteX4" y="connsiteY4"/>
+                    </a:cxn>
+                    <a:cxn ang="0">
+                      <a:pos x="connsiteX5" y="connsiteY5"/>
+                    </a:cxn>
+                    <a:cxn ang="0">
+                      <a:pos x="connsiteX6" y="connsiteY6"/>
+                    </a:cxn>
+                  </a:cxnLst>
+                  <a:rect l="l" t="t" r="r" b="b"/>
+                  <a:pathLst>
+                    <a:path w="409575" h="88475">
+                      <a:moveTo>
+                        <a:pt x="31220" y="0"/>
+                      </a:moveTo>
+                      <a:lnTo>
+                        <a:pt x="378355" y="0"/>
+                      </a:lnTo>
+                      <a:cubicBezTo>
+                        <a:pt x="395597" y="0"/>
+                        <a:pt x="409575" y="13978"/>
+                        <a:pt x="409575" y="31220"/>
+                      </a:cubicBezTo>
+                      <a:lnTo>
+                        <a:pt x="409575" y="88475"/>
+                      </a:lnTo>
+                      <a:lnTo>
+                        <a:pt x="0" y="88475"/>
+                      </a:lnTo>
+                      <a:lnTo>
+                        <a:pt x="0" y="31220"/>
+                      </a:lnTo>
+                      <a:cubicBezTo>
+                        <a:pt x="0" y="13978"/>
+                        <a:pt x="13978" y="0"/>
+                        <a:pt x="31220" y="0"/>
+                      </a:cubicBezTo>
+                      <a:close/>
+                    </a:path>
+                  </a:pathLst>
+                </a:custGeom>
+                <a:solidFill>
+                  <a:srgbClr val="C0CAD9"/>
+                </a:solidFill>
+                <a:ln w="12700">
+                  <a:solidFill>
+                    <a:srgbClr val="265598"/>
+                  </a:solidFill>
+                </a:ln>
+              </p:spPr>
+              <p:style>
+                <a:lnRef idx="2">
+                  <a:schemeClr val="accent1">
+                    <a:shade val="50000"/>
+                  </a:schemeClr>
+                </a:lnRef>
+                <a:fillRef idx="1">
+                  <a:schemeClr val="accent1"/>
+                </a:fillRef>
+                <a:effectRef idx="0">
+                  <a:schemeClr val="accent1"/>
+                </a:effectRef>
+                <a:fontRef idx="minor">
+                  <a:schemeClr val="lt1"/>
+                </a:fontRef>
+              </p:style>
+              <p:txBody>
+                <a:bodyPr wrap="square" rtlCol="0" anchor="ctr">
+                  <a:noAutofit/>
+                </a:bodyPr>
+                <a:lstStyle/>
+                <a:p>
+                  <a:pPr algn="ctr"/>
+                  <a:endParaRPr lang="en-US" b="1" dirty="0">
+                    <a:latin typeface="Arial" pitchFamily="34" charset="0"/>
+                    <a:cs typeface="Arial" pitchFamily="34" charset="0"/>
+                  </a:endParaRPr>
+                </a:p>
+              </p:txBody>
+            </p:sp>
+          </p:grpSp>
+        </p:grpSp>
+        <p:grpSp>
+          <p:nvGrpSpPr>
+            <p:cNvPr id="7" name="Group 6">
+              <a:extLst>
+                <a:ext uri="{FF2B5EF4-FFF2-40B4-BE49-F238E27FC236}">
+                  <a16:creationId xmlns:a16="http://schemas.microsoft.com/office/drawing/2014/main" id="{AC9382C9-956C-F3F3-0809-53523027A235}"/>
+                </a:ext>
+              </a:extLst>
+            </p:cNvPr>
+            <p:cNvGrpSpPr/>
+            <p:nvPr/>
+          </p:nvGrpSpPr>
+          <p:grpSpPr>
+            <a:xfrm>
+              <a:off x="2250624" y="4248931"/>
+              <a:ext cx="1857253" cy="653758"/>
+              <a:chOff x="2163122" y="5192193"/>
+              <a:chExt cx="1857253" cy="653758"/>
+            </a:xfrm>
+          </p:grpSpPr>
+          <p:sp>
+            <p:nvSpPr>
+              <p:cNvPr id="8" name="Rectangle: Rounded Corners 7">
+                <a:extLst>
+                  <a:ext uri="{FF2B5EF4-FFF2-40B4-BE49-F238E27FC236}">
+                    <a16:creationId xmlns:a16="http://schemas.microsoft.com/office/drawing/2014/main" id="{E1593092-2854-B838-FCBE-589626A9E937}"/>
+                  </a:ext>
+                </a:extLst>
+              </p:cNvPr>
+              <p:cNvSpPr/>
+              <p:nvPr/>
+            </p:nvSpPr>
+            <p:spPr>
+              <a:xfrm>
+                <a:off x="2296825" y="5262541"/>
+                <a:ext cx="1723550" cy="508651"/>
+              </a:xfrm>
+              <a:prstGeom prst="roundRect">
+                <a:avLst>
+                  <a:gd name="adj" fmla="val 8351"/>
+                </a:avLst>
+              </a:prstGeom>
+              <a:solidFill>
+                <a:srgbClr val="283645"/>
+              </a:solidFill>
+              <a:ln>
+                <a:noFill/>
+              </a:ln>
+            </p:spPr>
+            <p:style>
+              <a:lnRef idx="2">
+                <a:schemeClr val="accent1">
+                  <a:shade val="50000"/>
+                </a:schemeClr>
+              </a:lnRef>
+              <a:fillRef idx="1">
+                <a:schemeClr val="accent1"/>
+              </a:fillRef>
+              <a:effectRef idx="0">
+                <a:schemeClr val="accent1"/>
+              </a:effectRef>
+              <a:fontRef idx="minor">
+                <a:schemeClr val="lt1"/>
+              </a:fontRef>
+            </p:style>
+            <p:txBody>
+              <a:bodyPr rtlCol="0" anchor="ctr"/>
+              <a:lstStyle/>
+              <a:p>
+                <a:pPr algn="ctr"/>
+                <a:endParaRPr lang="en-US" b="1" dirty="0">
+                  <a:latin typeface="Arial" pitchFamily="34" charset="0"/>
+                  <a:cs typeface="Arial" pitchFamily="34" charset="0"/>
+                </a:endParaRPr>
+              </a:p>
+            </p:txBody>
+          </p:sp>
+          <p:sp>
+            <p:nvSpPr>
+              <p:cNvPr id="9" name="TextBox 8">
+                <a:extLst>
+                  <a:ext uri="{FF2B5EF4-FFF2-40B4-BE49-F238E27FC236}">
+                    <a16:creationId xmlns:a16="http://schemas.microsoft.com/office/drawing/2014/main" id="{EB1BEAFF-93B8-4928-D065-09019F5D2B31}"/>
+                  </a:ext>
+                </a:extLst>
+              </p:cNvPr>
+              <p:cNvSpPr txBox="1"/>
+              <p:nvPr/>
+            </p:nvSpPr>
+            <p:spPr>
+              <a:xfrm>
+                <a:off x="2163122" y="5350446"/>
+                <a:ext cx="1807322" cy="495505"/>
+              </a:xfrm>
+              <a:prstGeom prst="rect">
+                <a:avLst/>
+              </a:prstGeom>
+              <a:noFill/>
+            </p:spPr>
+            <p:txBody>
+              <a:bodyPr wrap="none" rtlCol="0">
+                <a:spAutoFit/>
+              </a:bodyPr>
+              <a:lstStyle/>
+              <a:p>
+                <a:pPr algn="ctr"/>
+                <a:r>
+                  <a:rPr lang="en-US" sz="700" b="1" dirty="0">
+                    <a:solidFill>
+                      <a:srgbClr val="C55A11"/>
+                    </a:solidFill>
+                    <a:latin typeface="Lucida Sans Typewriter" panose="020B0509030504030204" pitchFamily="49" charset="0"/>
+                  </a:rPr>
+                  <a:t> Connector</a:t>
+                </a:r>
+              </a:p>
+            </p:txBody>
+          </p:sp>
+          <p:sp>
+            <p:nvSpPr>
+              <p:cNvPr id="10" name="TextBox 9">
+                <a:extLst>
+                  <a:ext uri="{FF2B5EF4-FFF2-40B4-BE49-F238E27FC236}">
+                    <a16:creationId xmlns:a16="http://schemas.microsoft.com/office/drawing/2014/main" id="{59F82D56-38A7-5A2F-11B9-9D33A6533DC4}"/>
+                  </a:ext>
+                </a:extLst>
+              </p:cNvPr>
+              <p:cNvSpPr txBox="1"/>
+              <p:nvPr/>
+            </p:nvSpPr>
+            <p:spPr>
+              <a:xfrm>
+                <a:off x="2258745" y="5192193"/>
+                <a:ext cx="1132353" cy="495505"/>
+              </a:xfrm>
+              <a:prstGeom prst="rect">
+                <a:avLst/>
+              </a:prstGeom>
+              <a:noFill/>
+            </p:spPr>
+            <p:txBody>
+              <a:bodyPr wrap="none" rtlCol="0">
+                <a:spAutoFit/>
+              </a:bodyPr>
+              <a:lstStyle/>
+              <a:p>
+                <a:pPr algn="ctr">
+                  <a:spcAft>
+                    <a:spcPts val="1200"/>
+                  </a:spcAft>
+                </a:pPr>
+                <a:r>
+                  <a:rPr lang="en-US" sz="700" b="1" dirty="0">
+                    <a:solidFill>
+                      <a:schemeClr val="bg1"/>
+                    </a:solidFill>
+                    <a:latin typeface="Lucida Sans Typewriter" panose="020B0509030504030204" pitchFamily="49" charset="0"/>
+                  </a:rPr>
+                  <a:t>SysML</a:t>
+                </a:r>
+              </a:p>
+            </p:txBody>
+          </p:sp>
+        </p:grpSp>
+      </p:grpSp>
+      <p:grpSp>
+        <p:nvGrpSpPr>
+          <p:cNvPr id="28" name="Group 27">
+            <a:extLst>
+              <a:ext uri="{FF2B5EF4-FFF2-40B4-BE49-F238E27FC236}">
+                <a16:creationId xmlns:a16="http://schemas.microsoft.com/office/drawing/2014/main" id="{EE428861-B6DA-3C65-7B94-887C52C219EA}"/>
+              </a:ext>
+            </a:extLst>
+          </p:cNvPr>
+          <p:cNvGrpSpPr/>
+          <p:nvPr/>
+        </p:nvGrpSpPr>
+        <p:grpSpPr>
+          <a:xfrm>
+            <a:off x="1183005" y="1064029"/>
+            <a:ext cx="1173560" cy="1332467"/>
+            <a:chOff x="338095" y="379809"/>
+            <a:chExt cx="1994726" cy="2264824"/>
+          </a:xfrm>
+        </p:grpSpPr>
+        <p:sp>
+          <p:nvSpPr>
+            <p:cNvPr id="29" name="Rectangle: Rounded Corners 28">
+              <a:extLst>
+                <a:ext uri="{FF2B5EF4-FFF2-40B4-BE49-F238E27FC236}">
+                  <a16:creationId xmlns:a16="http://schemas.microsoft.com/office/drawing/2014/main" id="{FAE516AE-738C-06E9-AE7F-7671F3EDFB61}"/>
+                </a:ext>
+              </a:extLst>
+            </p:cNvPr>
+            <p:cNvSpPr/>
+            <p:nvPr/>
+          </p:nvSpPr>
+          <p:spPr>
+            <a:xfrm>
+              <a:off x="338095" y="379809"/>
+              <a:ext cx="1994726" cy="2264824"/>
+            </a:xfrm>
+            <a:prstGeom prst="roundRect">
+              <a:avLst>
+                <a:gd name="adj" fmla="val 8003"/>
+              </a:avLst>
+            </a:prstGeom>
+            <a:noFill/>
+            <a:ln>
+              <a:solidFill>
+                <a:schemeClr val="bg1">
+                  <a:lumMod val="50000"/>
+                </a:schemeClr>
+              </a:solidFill>
+            </a:ln>
+          </p:spPr>
+          <p:style>
+            <a:lnRef idx="2">
+              <a:schemeClr val="accent1">
+                <a:shade val="50000"/>
+              </a:schemeClr>
+            </a:lnRef>
+            <a:fillRef idx="1">
+              <a:schemeClr val="accent1"/>
+            </a:fillRef>
+            <a:effectRef idx="0">
+              <a:schemeClr val="accent1"/>
+            </a:effectRef>
+            <a:fontRef idx="minor">
+              <a:schemeClr val="lt1"/>
+            </a:fontRef>
+          </p:style>
+          <p:txBody>
+            <a:bodyPr rtlCol="0" anchor="ctr"/>
+            <a:lstStyle/>
+            <a:p>
+              <a:pPr algn="ctr"/>
+              <a:endParaRPr lang="en-US" b="1" dirty="0">
+                <a:latin typeface="Arial" pitchFamily="34" charset="0"/>
+                <a:cs typeface="Arial" pitchFamily="34" charset="0"/>
+              </a:endParaRPr>
+            </a:p>
+          </p:txBody>
+        </p:sp>
+        <p:grpSp>
+          <p:nvGrpSpPr>
+            <p:cNvPr id="30" name="Group 29">
+              <a:extLst>
+                <a:ext uri="{FF2B5EF4-FFF2-40B4-BE49-F238E27FC236}">
+                  <a16:creationId xmlns:a16="http://schemas.microsoft.com/office/drawing/2014/main" id="{4F4F6DD4-ED68-A302-B1B5-4FCFF56AF8A2}"/>
+                </a:ext>
+              </a:extLst>
+            </p:cNvPr>
+            <p:cNvGrpSpPr/>
+            <p:nvPr/>
+          </p:nvGrpSpPr>
+          <p:grpSpPr>
+            <a:xfrm>
+              <a:off x="765429" y="607918"/>
+              <a:ext cx="1123950" cy="1054173"/>
+              <a:chOff x="2255499" y="3431581"/>
+              <a:chExt cx="1123950" cy="1054173"/>
+            </a:xfrm>
+          </p:grpSpPr>
+          <p:sp>
+            <p:nvSpPr>
+              <p:cNvPr id="35" name="Rectangle: Rounded Corners 34">
+                <a:extLst>
+                  <a:ext uri="{FF2B5EF4-FFF2-40B4-BE49-F238E27FC236}">
+                    <a16:creationId xmlns:a16="http://schemas.microsoft.com/office/drawing/2014/main" id="{2BA266CF-8D57-CDC8-8993-A7E14E068CFB}"/>
+                  </a:ext>
+                </a:extLst>
+              </p:cNvPr>
+              <p:cNvSpPr/>
+              <p:nvPr/>
+            </p:nvSpPr>
+            <p:spPr>
+              <a:xfrm>
+                <a:off x="2255499" y="3431581"/>
+                <a:ext cx="1123950" cy="1054173"/>
+              </a:xfrm>
+              <a:prstGeom prst="roundRect">
+                <a:avLst/>
+              </a:prstGeom>
+              <a:gradFill flip="none" rotWithShape="1">
+                <a:gsLst>
+                  <a:gs pos="75000">
+                    <a:schemeClr val="bg1"/>
+                  </a:gs>
+                  <a:gs pos="16000">
+                    <a:schemeClr val="bg1">
+                      <a:lumMod val="85000"/>
+                    </a:schemeClr>
+                  </a:gs>
+                </a:gsLst>
+                <a:lin ang="16200000" scaled="1"/>
+                <a:tileRect/>
+              </a:gradFill>
+              <a:ln>
+                <a:solidFill>
+                  <a:srgbClr val="C55A11"/>
+                </a:solidFill>
+              </a:ln>
+            </p:spPr>
+            <p:style>
+              <a:lnRef idx="2">
+                <a:schemeClr val="accent1">
+                  <a:shade val="50000"/>
+                </a:schemeClr>
+              </a:lnRef>
+              <a:fillRef idx="1">
+                <a:schemeClr val="accent1"/>
+              </a:fillRef>
+              <a:effectRef idx="0">
+                <a:schemeClr val="accent1"/>
+              </a:effectRef>
+              <a:fontRef idx="minor">
+                <a:schemeClr val="lt1"/>
+              </a:fontRef>
+            </p:style>
+            <p:txBody>
+              <a:bodyPr rtlCol="0" anchor="ctr"/>
+              <a:lstStyle/>
+              <a:p>
+                <a:pPr algn="ctr"/>
+                <a:endParaRPr lang="en-US" b="1" dirty="0">
+                  <a:latin typeface="Arial" pitchFamily="34" charset="0"/>
+                  <a:cs typeface="Arial" pitchFamily="34" charset="0"/>
+                </a:endParaRPr>
+              </a:p>
+            </p:txBody>
+          </p:sp>
+          <p:cxnSp>
+            <p:nvCxnSpPr>
+              <p:cNvPr id="36" name="Straight Connector 35">
+                <a:extLst>
+                  <a:ext uri="{FF2B5EF4-FFF2-40B4-BE49-F238E27FC236}">
+                    <a16:creationId xmlns:a16="http://schemas.microsoft.com/office/drawing/2014/main" id="{E90D512F-C10F-CD77-82B2-B8A2A61E05D1}"/>
+                  </a:ext>
+                </a:extLst>
+              </p:cNvPr>
+              <p:cNvCxnSpPr>
+                <a:cxnSpLocks/>
+              </p:cNvCxnSpPr>
+              <p:nvPr/>
+            </p:nvCxnSpPr>
+            <p:spPr>
+              <a:xfrm>
+                <a:off x="2795588" y="3743482"/>
+                <a:ext cx="198098" cy="0"/>
+              </a:xfrm>
+              <a:prstGeom prst="line">
+                <a:avLst/>
+              </a:prstGeom>
+              <a:ln w="19050">
+                <a:solidFill>
+                  <a:srgbClr val="2D5B9C"/>
+                </a:solidFill>
+              </a:ln>
+            </p:spPr>
+            <p:style>
+              <a:lnRef idx="1">
+                <a:schemeClr val="accent1"/>
+              </a:lnRef>
+              <a:fillRef idx="0">
+                <a:schemeClr val="accent1"/>
+              </a:fillRef>
+              <a:effectRef idx="0">
+                <a:schemeClr val="accent1"/>
+              </a:effectRef>
+              <a:fontRef idx="minor">
+                <a:schemeClr val="tx1"/>
+              </a:fontRef>
+            </p:style>
+          </p:cxnSp>
+          <p:grpSp>
+            <p:nvGrpSpPr>
+              <p:cNvPr id="37" name="Group 36">
+                <a:extLst>
+                  <a:ext uri="{FF2B5EF4-FFF2-40B4-BE49-F238E27FC236}">
+                    <a16:creationId xmlns:a16="http://schemas.microsoft.com/office/drawing/2014/main" id="{02464B41-C875-1F5B-ACD5-EC16C99FFAE9}"/>
+                  </a:ext>
+                </a:extLst>
+              </p:cNvPr>
+              <p:cNvGrpSpPr/>
+              <p:nvPr/>
+            </p:nvGrpSpPr>
+            <p:grpSpPr>
+              <a:xfrm>
+                <a:off x="2993686" y="3615775"/>
+                <a:ext cx="314326" cy="263814"/>
+                <a:chOff x="3676649" y="3745954"/>
+                <a:chExt cx="314326" cy="263814"/>
+              </a:xfrm>
+            </p:grpSpPr>
+            <p:sp>
+              <p:nvSpPr>
+                <p:cNvPr id="50" name="Rectangle: Rounded Corners 49">
+                  <a:extLst>
+                    <a:ext uri="{FF2B5EF4-FFF2-40B4-BE49-F238E27FC236}">
+                      <a16:creationId xmlns:a16="http://schemas.microsoft.com/office/drawing/2014/main" id="{A2C212DC-FAF3-9F3C-FF11-D6883C5FE71F}"/>
+                    </a:ext>
+                  </a:extLst>
+                </p:cNvPr>
+                <p:cNvSpPr/>
+                <p:nvPr/>
+              </p:nvSpPr>
+              <p:spPr>
+                <a:xfrm>
+                  <a:off x="3676650" y="3745954"/>
+                  <a:ext cx="314325" cy="263814"/>
+                </a:xfrm>
+                <a:prstGeom prst="roundRect">
+                  <a:avLst>
+                    <a:gd name="adj" fmla="val 9455"/>
+                  </a:avLst>
+                </a:prstGeom>
+                <a:solidFill>
+                  <a:schemeClr val="bg1"/>
+                </a:solidFill>
+                <a:ln>
+                  <a:solidFill>
+                    <a:srgbClr val="265598"/>
+                  </a:solidFill>
+                </a:ln>
+              </p:spPr>
+              <p:style>
+                <a:lnRef idx="2">
+                  <a:schemeClr val="accent1">
+                    <a:shade val="50000"/>
+                  </a:schemeClr>
+                </a:lnRef>
+                <a:fillRef idx="1">
+                  <a:schemeClr val="accent1"/>
+                </a:fillRef>
+                <a:effectRef idx="0">
+                  <a:schemeClr val="accent1"/>
+                </a:effectRef>
+                <a:fontRef idx="minor">
+                  <a:schemeClr val="lt1"/>
+                </a:fontRef>
+              </p:style>
+              <p:txBody>
+                <a:bodyPr rtlCol="0" anchor="ctr"/>
+                <a:lstStyle/>
+                <a:p>
+                  <a:pPr algn="ctr"/>
+                  <a:endParaRPr lang="en-US" b="1" dirty="0">
+                    <a:latin typeface="Arial" pitchFamily="34" charset="0"/>
+                    <a:cs typeface="Arial" pitchFamily="34" charset="0"/>
+                  </a:endParaRPr>
+                </a:p>
+              </p:txBody>
+            </p:sp>
+            <p:sp>
+              <p:nvSpPr>
+                <p:cNvPr id="51" name="Freeform: Shape 50">
+                  <a:extLst>
+                    <a:ext uri="{FF2B5EF4-FFF2-40B4-BE49-F238E27FC236}">
+                      <a16:creationId xmlns:a16="http://schemas.microsoft.com/office/drawing/2014/main" id="{DAF7B80A-0C76-9068-BAA6-A68EA4932E58}"/>
+                    </a:ext>
+                  </a:extLst>
+                </p:cNvPr>
+                <p:cNvSpPr/>
+                <p:nvPr/>
+              </p:nvSpPr>
+              <p:spPr>
+                <a:xfrm>
+                  <a:off x="3676649" y="3745955"/>
+                  <a:ext cx="314325" cy="88475"/>
+                </a:xfrm>
+                <a:custGeom>
+                  <a:avLst/>
+                  <a:gdLst>
+                    <a:gd name="connsiteX0" fmla="*/ 31220 w 409575"/>
+                    <a:gd name="connsiteY0" fmla="*/ 0 h 88475"/>
+                    <a:gd name="connsiteX1" fmla="*/ 378355 w 409575"/>
+                    <a:gd name="connsiteY1" fmla="*/ 0 h 88475"/>
+                    <a:gd name="connsiteX2" fmla="*/ 409575 w 409575"/>
+                    <a:gd name="connsiteY2" fmla="*/ 31220 h 88475"/>
+                    <a:gd name="connsiteX3" fmla="*/ 409575 w 409575"/>
+                    <a:gd name="connsiteY3" fmla="*/ 88475 h 88475"/>
+                    <a:gd name="connsiteX4" fmla="*/ 0 w 409575"/>
+                    <a:gd name="connsiteY4" fmla="*/ 88475 h 88475"/>
+                    <a:gd name="connsiteX5" fmla="*/ 0 w 409575"/>
+                    <a:gd name="connsiteY5" fmla="*/ 31220 h 88475"/>
+                    <a:gd name="connsiteX6" fmla="*/ 31220 w 409575"/>
+                    <a:gd name="connsiteY6" fmla="*/ 0 h 88475"/>
+                  </a:gdLst>
+                  <a:ahLst/>
+                  <a:cxnLst>
+                    <a:cxn ang="0">
+                      <a:pos x="connsiteX0" y="connsiteY0"/>
+                    </a:cxn>
+                    <a:cxn ang="0">
+                      <a:pos x="connsiteX1" y="connsiteY1"/>
+                    </a:cxn>
+                    <a:cxn ang="0">
+                      <a:pos x="connsiteX2" y="connsiteY2"/>
+                    </a:cxn>
+                    <a:cxn ang="0">
+                      <a:pos x="connsiteX3" y="connsiteY3"/>
+                    </a:cxn>
+                    <a:cxn ang="0">
+                      <a:pos x="connsiteX4" y="connsiteY4"/>
+                    </a:cxn>
+                    <a:cxn ang="0">
+                      <a:pos x="connsiteX5" y="connsiteY5"/>
+                    </a:cxn>
+                    <a:cxn ang="0">
+                      <a:pos x="connsiteX6" y="connsiteY6"/>
+                    </a:cxn>
+                  </a:cxnLst>
+                  <a:rect l="l" t="t" r="r" b="b"/>
+                  <a:pathLst>
+                    <a:path w="409575" h="88475">
+                      <a:moveTo>
+                        <a:pt x="31220" y="0"/>
+                      </a:moveTo>
+                      <a:lnTo>
+                        <a:pt x="378355" y="0"/>
+                      </a:lnTo>
+                      <a:cubicBezTo>
+                        <a:pt x="395597" y="0"/>
+                        <a:pt x="409575" y="13978"/>
+                        <a:pt x="409575" y="31220"/>
+                      </a:cubicBezTo>
+                      <a:lnTo>
+                        <a:pt x="409575" y="88475"/>
+                      </a:lnTo>
+                      <a:lnTo>
+                        <a:pt x="0" y="88475"/>
+                      </a:lnTo>
+                      <a:lnTo>
+                        <a:pt x="0" y="31220"/>
+                      </a:lnTo>
+                      <a:cubicBezTo>
+                        <a:pt x="0" y="13978"/>
+                        <a:pt x="13978" y="0"/>
+                        <a:pt x="31220" y="0"/>
+                      </a:cubicBezTo>
+                      <a:close/>
+                    </a:path>
+                  </a:pathLst>
+                </a:custGeom>
+                <a:solidFill>
+                  <a:srgbClr val="C0CAD9"/>
+                </a:solidFill>
+                <a:ln>
+                  <a:solidFill>
+                    <a:srgbClr val="265598"/>
+                  </a:solidFill>
+                </a:ln>
+              </p:spPr>
+              <p:style>
+                <a:lnRef idx="2">
+                  <a:schemeClr val="accent1">
+                    <a:shade val="50000"/>
+                  </a:schemeClr>
+                </a:lnRef>
+                <a:fillRef idx="1">
+                  <a:schemeClr val="accent1"/>
+                </a:fillRef>
+                <a:effectRef idx="0">
+                  <a:schemeClr val="accent1"/>
+                </a:effectRef>
+                <a:fontRef idx="minor">
+                  <a:schemeClr val="lt1"/>
+                </a:fontRef>
+              </p:style>
+              <p:txBody>
+                <a:bodyPr wrap="square" rtlCol="0" anchor="ctr">
+                  <a:noAutofit/>
+                </a:bodyPr>
+                <a:lstStyle/>
+                <a:p>
+                  <a:pPr algn="ctr"/>
+                  <a:endParaRPr lang="en-US" b="1" dirty="0">
+                    <a:latin typeface="Arial" pitchFamily="34" charset="0"/>
+                    <a:cs typeface="Arial" pitchFamily="34" charset="0"/>
+                  </a:endParaRPr>
+                </a:p>
+              </p:txBody>
+            </p:sp>
+          </p:grpSp>
+          <p:cxnSp>
+            <p:nvCxnSpPr>
+              <p:cNvPr id="38" name="Connector: Elbow 37">
+                <a:extLst>
+                  <a:ext uri="{FF2B5EF4-FFF2-40B4-BE49-F238E27FC236}">
+                    <a16:creationId xmlns:a16="http://schemas.microsoft.com/office/drawing/2014/main" id="{C97620FF-0781-A064-B901-A241BB266A50}"/>
+                  </a:ext>
+                </a:extLst>
+              </p:cNvPr>
+              <p:cNvCxnSpPr>
+                <a:cxnSpLocks/>
+                <a:stCxn id="42" idx="2"/>
+                <a:endCxn id="41" idx="0"/>
+              </p:cNvCxnSpPr>
+              <p:nvPr/>
+            </p:nvCxnSpPr>
+            <p:spPr>
+              <a:xfrm rot="5400000">
+                <a:off x="2370526" y="3929137"/>
+                <a:ext cx="313852" cy="164887"/>
+              </a:xfrm>
+              <a:prstGeom prst="bentConnector3">
+                <a:avLst>
+                  <a:gd name="adj1" fmla="val 50000"/>
+                </a:avLst>
+              </a:prstGeom>
+              <a:ln w="19050">
+                <a:solidFill>
+                  <a:srgbClr val="4E4F4E"/>
+                </a:solidFill>
+              </a:ln>
+            </p:spPr>
+            <p:style>
+              <a:lnRef idx="1">
+                <a:schemeClr val="accent1"/>
+              </a:lnRef>
+              <a:fillRef idx="0">
+                <a:schemeClr val="accent1"/>
+              </a:fillRef>
+              <a:effectRef idx="0">
+                <a:schemeClr val="accent1"/>
+              </a:effectRef>
+              <a:fontRef idx="minor">
+                <a:schemeClr val="tx1"/>
+              </a:fontRef>
+            </p:style>
+          </p:cxnSp>
+          <p:cxnSp>
+            <p:nvCxnSpPr>
+              <p:cNvPr id="39" name="Connector: Elbow 38">
+                <a:extLst>
+                  <a:ext uri="{FF2B5EF4-FFF2-40B4-BE49-F238E27FC236}">
+                    <a16:creationId xmlns:a16="http://schemas.microsoft.com/office/drawing/2014/main" id="{01D46444-C242-2071-4CA5-C94FF42ED5B8}"/>
+                  </a:ext>
+                </a:extLst>
+              </p:cNvPr>
+              <p:cNvCxnSpPr>
+                <a:cxnSpLocks/>
+                <a:stCxn id="42" idx="2"/>
+                <a:endCxn id="40" idx="0"/>
+              </p:cNvCxnSpPr>
+              <p:nvPr/>
+            </p:nvCxnSpPr>
+            <p:spPr>
+              <a:xfrm rot="16200000" flipH="1">
+                <a:off x="2527171" y="3937377"/>
+                <a:ext cx="308437" cy="142989"/>
+              </a:xfrm>
+              <a:prstGeom prst="bentConnector3">
+                <a:avLst>
+                  <a:gd name="adj1" fmla="val 50772"/>
+                </a:avLst>
+              </a:prstGeom>
+              <a:ln w="19050">
+                <a:solidFill>
+                  <a:srgbClr val="4E4F4E"/>
+                </a:solidFill>
+              </a:ln>
+            </p:spPr>
+            <p:style>
+              <a:lnRef idx="1">
+                <a:schemeClr val="accent1"/>
+              </a:lnRef>
+              <a:fillRef idx="0">
+                <a:schemeClr val="accent1"/>
+              </a:fillRef>
+              <a:effectRef idx="0">
+                <a:schemeClr val="accent1"/>
+              </a:effectRef>
+              <a:fontRef idx="minor">
+                <a:schemeClr val="tx1"/>
+              </a:fontRef>
+            </p:style>
+          </p:cxnSp>
+          <p:sp>
+            <p:nvSpPr>
+              <p:cNvPr id="40" name="Rectangle 39">
+                <a:extLst>
+                  <a:ext uri="{FF2B5EF4-FFF2-40B4-BE49-F238E27FC236}">
+                    <a16:creationId xmlns:a16="http://schemas.microsoft.com/office/drawing/2014/main" id="{C14969D7-94C9-EAF4-883D-089E751AC6D7}"/>
+                  </a:ext>
+                </a:extLst>
+              </p:cNvPr>
+              <p:cNvSpPr/>
+              <p:nvPr/>
+            </p:nvSpPr>
+            <p:spPr>
+              <a:xfrm>
+                <a:off x="2634516" y="4163091"/>
+                <a:ext cx="236735" cy="197686"/>
+              </a:xfrm>
+              <a:prstGeom prst="rect">
+                <a:avLst/>
+              </a:prstGeom>
+              <a:gradFill flip="none" rotWithShape="1">
+                <a:gsLst>
+                  <a:gs pos="0">
+                    <a:srgbClr val="FFD752">
+                      <a:shade val="30000"/>
+                      <a:satMod val="115000"/>
+                    </a:srgbClr>
+                  </a:gs>
+                  <a:gs pos="27000">
+                    <a:srgbClr val="FFD752">
+                      <a:shade val="67500"/>
+                      <a:satMod val="115000"/>
+                    </a:srgbClr>
+                  </a:gs>
+                  <a:gs pos="100000">
+                    <a:schemeClr val="bg1">
+                      <a:lumMod val="95000"/>
+                    </a:schemeClr>
+                  </a:gs>
+                  <a:gs pos="60000">
+                    <a:srgbClr val="FFD752">
+                      <a:shade val="100000"/>
+                      <a:satMod val="115000"/>
+                    </a:srgbClr>
+                  </a:gs>
+                </a:gsLst>
+                <a:lin ang="16200000" scaled="1"/>
+                <a:tileRect/>
+              </a:gradFill>
+              <a:ln>
+                <a:solidFill>
+                  <a:srgbClr val="76622B"/>
+                </a:solidFill>
+              </a:ln>
+            </p:spPr>
+            <p:style>
+              <a:lnRef idx="2">
+                <a:schemeClr val="accent1">
+                  <a:shade val="50000"/>
+                </a:schemeClr>
+              </a:lnRef>
+              <a:fillRef idx="1">
+                <a:schemeClr val="accent1"/>
+              </a:fillRef>
+              <a:effectRef idx="0">
+                <a:schemeClr val="accent1"/>
+              </a:effectRef>
+              <a:fontRef idx="minor">
+                <a:schemeClr val="lt1"/>
+              </a:fontRef>
+            </p:style>
+            <p:txBody>
+              <a:bodyPr rtlCol="0" anchor="ctr"/>
+              <a:lstStyle/>
+              <a:p>
+                <a:pPr algn="ctr"/>
+                <a:endParaRPr lang="en-US" b="1" dirty="0">
+                  <a:latin typeface="Arial" pitchFamily="34" charset="0"/>
+                  <a:cs typeface="Arial" pitchFamily="34" charset="0"/>
+                </a:endParaRPr>
+              </a:p>
+            </p:txBody>
+          </p:sp>
+          <p:sp>
+            <p:nvSpPr>
+              <p:cNvPr id="41" name="Rectangle 40">
+                <a:extLst>
+                  <a:ext uri="{FF2B5EF4-FFF2-40B4-BE49-F238E27FC236}">
+                    <a16:creationId xmlns:a16="http://schemas.microsoft.com/office/drawing/2014/main" id="{D1140298-944B-16C6-6B73-4796B77244B0}"/>
+                  </a:ext>
+                </a:extLst>
+              </p:cNvPr>
+              <p:cNvSpPr/>
+              <p:nvPr/>
+            </p:nvSpPr>
+            <p:spPr>
+              <a:xfrm>
+                <a:off x="2326640" y="4168506"/>
+                <a:ext cx="236735" cy="197686"/>
+              </a:xfrm>
+              <a:prstGeom prst="rect">
+                <a:avLst/>
+              </a:prstGeom>
+              <a:gradFill flip="none" rotWithShape="1">
+                <a:gsLst>
+                  <a:gs pos="0">
+                    <a:srgbClr val="FFD752">
+                      <a:shade val="30000"/>
+                      <a:satMod val="115000"/>
+                    </a:srgbClr>
+                  </a:gs>
+                  <a:gs pos="27000">
+                    <a:srgbClr val="FFD752">
+                      <a:shade val="67500"/>
+                      <a:satMod val="115000"/>
+                    </a:srgbClr>
+                  </a:gs>
+                  <a:gs pos="100000">
+                    <a:schemeClr val="bg1">
+                      <a:lumMod val="95000"/>
+                    </a:schemeClr>
+                  </a:gs>
+                  <a:gs pos="60000">
+                    <a:srgbClr val="FFD752">
+                      <a:shade val="100000"/>
+                      <a:satMod val="115000"/>
+                    </a:srgbClr>
+                  </a:gs>
+                </a:gsLst>
+                <a:lin ang="16200000" scaled="1"/>
+                <a:tileRect/>
+              </a:gradFill>
+              <a:ln>
+                <a:solidFill>
+                  <a:srgbClr val="76622B"/>
+                </a:solidFill>
+              </a:ln>
+            </p:spPr>
+            <p:style>
+              <a:lnRef idx="2">
+                <a:schemeClr val="accent1">
+                  <a:shade val="50000"/>
+                </a:schemeClr>
+              </a:lnRef>
+              <a:fillRef idx="1">
+                <a:schemeClr val="accent1"/>
+              </a:fillRef>
+              <a:effectRef idx="0">
+                <a:schemeClr val="accent1"/>
+              </a:effectRef>
+              <a:fontRef idx="minor">
+                <a:schemeClr val="lt1"/>
+              </a:fontRef>
+            </p:style>
+            <p:txBody>
+              <a:bodyPr rtlCol="0" anchor="ctr"/>
+              <a:lstStyle/>
+              <a:p>
+                <a:pPr algn="ctr"/>
+                <a:endParaRPr lang="en-US" b="1" dirty="0">
+                  <a:latin typeface="Arial" pitchFamily="34" charset="0"/>
+                  <a:cs typeface="Arial" pitchFamily="34" charset="0"/>
+                </a:endParaRPr>
+              </a:p>
+            </p:txBody>
+          </p:sp>
+          <p:sp>
+            <p:nvSpPr>
+              <p:cNvPr id="42" name="Rectangle 41">
+                <a:extLst>
+                  <a:ext uri="{FF2B5EF4-FFF2-40B4-BE49-F238E27FC236}">
+                    <a16:creationId xmlns:a16="http://schemas.microsoft.com/office/drawing/2014/main" id="{DC63ECBB-ABFC-EF7B-39D0-B83FA2DE5D57}"/>
+                  </a:ext>
+                </a:extLst>
+              </p:cNvPr>
+              <p:cNvSpPr/>
+              <p:nvPr/>
+            </p:nvSpPr>
+            <p:spPr>
+              <a:xfrm>
+                <a:off x="2476725" y="3656967"/>
+                <a:ext cx="266339" cy="197687"/>
+              </a:xfrm>
+              <a:prstGeom prst="rect">
+                <a:avLst/>
+              </a:prstGeom>
+              <a:gradFill flip="none" rotWithShape="1">
+                <a:gsLst>
+                  <a:gs pos="0">
+                    <a:srgbClr val="FFD752">
+                      <a:shade val="30000"/>
+                      <a:satMod val="115000"/>
+                    </a:srgbClr>
+                  </a:gs>
+                  <a:gs pos="27000">
+                    <a:srgbClr val="FFD752">
+                      <a:shade val="67500"/>
+                      <a:satMod val="115000"/>
+                    </a:srgbClr>
+                  </a:gs>
+                  <a:gs pos="100000">
+                    <a:schemeClr val="bg1">
+                      <a:lumMod val="95000"/>
+                    </a:schemeClr>
+                  </a:gs>
+                  <a:gs pos="60000">
+                    <a:srgbClr val="FFD752">
+                      <a:shade val="100000"/>
+                      <a:satMod val="115000"/>
+                    </a:srgbClr>
+                  </a:gs>
+                </a:gsLst>
+                <a:lin ang="16200000" scaled="1"/>
+                <a:tileRect/>
+              </a:gradFill>
+              <a:ln>
+                <a:solidFill>
+                  <a:srgbClr val="76622B"/>
+                </a:solidFill>
+              </a:ln>
+            </p:spPr>
+            <p:style>
+              <a:lnRef idx="2">
+                <a:schemeClr val="accent1">
+                  <a:shade val="50000"/>
+                </a:schemeClr>
+              </a:lnRef>
+              <a:fillRef idx="1">
+                <a:schemeClr val="accent1"/>
+              </a:fillRef>
+              <a:effectRef idx="0">
+                <a:schemeClr val="accent1"/>
+              </a:effectRef>
+              <a:fontRef idx="minor">
+                <a:schemeClr val="lt1"/>
+              </a:fontRef>
+            </p:style>
+            <p:txBody>
+              <a:bodyPr rtlCol="0" anchor="ctr"/>
+              <a:lstStyle/>
+              <a:p>
+                <a:pPr algn="ctr"/>
+                <a:endParaRPr lang="en-US" b="1" dirty="0">
+                  <a:latin typeface="Arial" pitchFamily="34" charset="0"/>
+                  <a:cs typeface="Arial" pitchFamily="34" charset="0"/>
+                </a:endParaRPr>
+              </a:p>
+            </p:txBody>
+          </p:sp>
+          <p:cxnSp>
+            <p:nvCxnSpPr>
+              <p:cNvPr id="43" name="Connector: Elbow 42">
+                <a:extLst>
+                  <a:ext uri="{FF2B5EF4-FFF2-40B4-BE49-F238E27FC236}">
+                    <a16:creationId xmlns:a16="http://schemas.microsoft.com/office/drawing/2014/main" id="{61F220D9-7294-A8D9-7445-2AC79C1B31BE}"/>
+                  </a:ext>
+                </a:extLst>
+              </p:cNvPr>
+              <p:cNvCxnSpPr>
+                <a:cxnSpLocks/>
+              </p:cNvCxnSpPr>
+              <p:nvPr/>
+            </p:nvCxnSpPr>
+            <p:spPr>
+              <a:xfrm rot="16200000" flipH="1">
+                <a:off x="2794384" y="3786082"/>
+                <a:ext cx="267834" cy="226246"/>
+              </a:xfrm>
+              <a:prstGeom prst="bentConnector3">
+                <a:avLst>
+                  <a:gd name="adj1" fmla="val 129128"/>
+                </a:avLst>
+              </a:prstGeom>
+              <a:ln w="19050">
+                <a:solidFill>
+                  <a:srgbClr val="2D5B9C"/>
+                </a:solidFill>
+              </a:ln>
+            </p:spPr>
+            <p:style>
+              <a:lnRef idx="1">
+                <a:schemeClr val="accent1"/>
+              </a:lnRef>
+              <a:fillRef idx="0">
+                <a:schemeClr val="accent1"/>
+              </a:fillRef>
+              <a:effectRef idx="0">
+                <a:schemeClr val="accent1"/>
+              </a:effectRef>
+              <a:fontRef idx="minor">
+                <a:schemeClr val="tx1"/>
+              </a:fontRef>
+            </p:style>
+          </p:cxnSp>
+          <p:grpSp>
+            <p:nvGrpSpPr>
+              <p:cNvPr id="44" name="Group 43">
+                <a:extLst>
+                  <a:ext uri="{FF2B5EF4-FFF2-40B4-BE49-F238E27FC236}">
+                    <a16:creationId xmlns:a16="http://schemas.microsoft.com/office/drawing/2014/main" id="{34EBD313-C336-6C66-40CD-55C51A8EFBE5}"/>
+                  </a:ext>
+                </a:extLst>
+              </p:cNvPr>
+              <p:cNvGrpSpPr/>
+              <p:nvPr/>
+            </p:nvGrpSpPr>
+            <p:grpSpPr>
+              <a:xfrm>
+                <a:off x="2986475" y="3995897"/>
+                <a:ext cx="314326" cy="263814"/>
+                <a:chOff x="3676650" y="4097710"/>
+                <a:chExt cx="314326" cy="263814"/>
+              </a:xfrm>
+            </p:grpSpPr>
+            <p:sp>
+              <p:nvSpPr>
+                <p:cNvPr id="48" name="Rectangle: Rounded Corners 47">
+                  <a:extLst>
+                    <a:ext uri="{FF2B5EF4-FFF2-40B4-BE49-F238E27FC236}">
+                      <a16:creationId xmlns:a16="http://schemas.microsoft.com/office/drawing/2014/main" id="{0AA37A8F-626A-5CA4-9128-2DB2DB002B60}"/>
+                    </a:ext>
+                  </a:extLst>
+                </p:cNvPr>
+                <p:cNvSpPr/>
+                <p:nvPr/>
+              </p:nvSpPr>
+              <p:spPr>
+                <a:xfrm>
+                  <a:off x="3676651" y="4097710"/>
+                  <a:ext cx="314325" cy="263814"/>
+                </a:xfrm>
+                <a:prstGeom prst="roundRect">
+                  <a:avLst>
+                    <a:gd name="adj" fmla="val 9455"/>
+                  </a:avLst>
+                </a:prstGeom>
+                <a:solidFill>
+                  <a:schemeClr val="bg1"/>
+                </a:solidFill>
+                <a:ln>
+                  <a:solidFill>
+                    <a:srgbClr val="265598"/>
+                  </a:solidFill>
+                </a:ln>
+              </p:spPr>
+              <p:style>
+                <a:lnRef idx="2">
+                  <a:schemeClr val="accent1">
+                    <a:shade val="50000"/>
+                  </a:schemeClr>
+                </a:lnRef>
+                <a:fillRef idx="1">
+                  <a:schemeClr val="accent1"/>
+                </a:fillRef>
+                <a:effectRef idx="0">
+                  <a:schemeClr val="accent1"/>
+                </a:effectRef>
+                <a:fontRef idx="minor">
+                  <a:schemeClr val="lt1"/>
+                </a:fontRef>
+              </p:style>
+              <p:txBody>
+                <a:bodyPr rtlCol="0" anchor="ctr"/>
+                <a:lstStyle/>
+                <a:p>
+                  <a:pPr algn="ctr"/>
+                  <a:endParaRPr lang="en-US" b="1" dirty="0">
+                    <a:latin typeface="Arial" pitchFamily="34" charset="0"/>
+                    <a:cs typeface="Arial" pitchFamily="34" charset="0"/>
+                  </a:endParaRPr>
+                </a:p>
+              </p:txBody>
+            </p:sp>
+            <p:sp>
+              <p:nvSpPr>
+                <p:cNvPr id="49" name="Freeform: Shape 48">
+                  <a:extLst>
+                    <a:ext uri="{FF2B5EF4-FFF2-40B4-BE49-F238E27FC236}">
+                      <a16:creationId xmlns:a16="http://schemas.microsoft.com/office/drawing/2014/main" id="{30CF48D6-21AC-0DD7-8033-307019B5B547}"/>
+                    </a:ext>
+                  </a:extLst>
+                </p:cNvPr>
+                <p:cNvSpPr/>
+                <p:nvPr/>
+              </p:nvSpPr>
+              <p:spPr>
+                <a:xfrm>
+                  <a:off x="3676650" y="4097711"/>
+                  <a:ext cx="314325" cy="88475"/>
+                </a:xfrm>
+                <a:custGeom>
+                  <a:avLst/>
+                  <a:gdLst>
+                    <a:gd name="connsiteX0" fmla="*/ 31220 w 409575"/>
+                    <a:gd name="connsiteY0" fmla="*/ 0 h 88475"/>
+                    <a:gd name="connsiteX1" fmla="*/ 378355 w 409575"/>
+                    <a:gd name="connsiteY1" fmla="*/ 0 h 88475"/>
+                    <a:gd name="connsiteX2" fmla="*/ 409575 w 409575"/>
+                    <a:gd name="connsiteY2" fmla="*/ 31220 h 88475"/>
+                    <a:gd name="connsiteX3" fmla="*/ 409575 w 409575"/>
+                    <a:gd name="connsiteY3" fmla="*/ 88475 h 88475"/>
+                    <a:gd name="connsiteX4" fmla="*/ 0 w 409575"/>
+                    <a:gd name="connsiteY4" fmla="*/ 88475 h 88475"/>
+                    <a:gd name="connsiteX5" fmla="*/ 0 w 409575"/>
+                    <a:gd name="connsiteY5" fmla="*/ 31220 h 88475"/>
+                    <a:gd name="connsiteX6" fmla="*/ 31220 w 409575"/>
+                    <a:gd name="connsiteY6" fmla="*/ 0 h 88475"/>
+                  </a:gdLst>
+                  <a:ahLst/>
+                  <a:cxnLst>
+                    <a:cxn ang="0">
+                      <a:pos x="connsiteX0" y="connsiteY0"/>
+                    </a:cxn>
+                    <a:cxn ang="0">
+                      <a:pos x="connsiteX1" y="connsiteY1"/>
+                    </a:cxn>
+                    <a:cxn ang="0">
+                      <a:pos x="connsiteX2" y="connsiteY2"/>
+                    </a:cxn>
+                    <a:cxn ang="0">
+                      <a:pos x="connsiteX3" y="connsiteY3"/>
+                    </a:cxn>
+                    <a:cxn ang="0">
+                      <a:pos x="connsiteX4" y="connsiteY4"/>
+                    </a:cxn>
+                    <a:cxn ang="0">
+                      <a:pos x="connsiteX5" y="connsiteY5"/>
+                    </a:cxn>
+                    <a:cxn ang="0">
+                      <a:pos x="connsiteX6" y="connsiteY6"/>
+                    </a:cxn>
+                  </a:cxnLst>
+                  <a:rect l="l" t="t" r="r" b="b"/>
+                  <a:pathLst>
+                    <a:path w="409575" h="88475">
+                      <a:moveTo>
+                        <a:pt x="31220" y="0"/>
+                      </a:moveTo>
+                      <a:lnTo>
+                        <a:pt x="378355" y="0"/>
+                      </a:lnTo>
+                      <a:cubicBezTo>
+                        <a:pt x="395597" y="0"/>
+                        <a:pt x="409575" y="13978"/>
+                        <a:pt x="409575" y="31220"/>
+                      </a:cubicBezTo>
+                      <a:lnTo>
+                        <a:pt x="409575" y="88475"/>
+                      </a:lnTo>
+                      <a:lnTo>
+                        <a:pt x="0" y="88475"/>
+                      </a:lnTo>
+                      <a:lnTo>
+                        <a:pt x="0" y="31220"/>
+                      </a:lnTo>
+                      <a:cubicBezTo>
+                        <a:pt x="0" y="13978"/>
+                        <a:pt x="13978" y="0"/>
+                        <a:pt x="31220" y="0"/>
+                      </a:cubicBezTo>
+                      <a:close/>
+                    </a:path>
+                  </a:pathLst>
+                </a:custGeom>
+                <a:solidFill>
+                  <a:srgbClr val="C0CAD9"/>
+                </a:solidFill>
+                <a:ln>
+                  <a:solidFill>
+                    <a:srgbClr val="265598"/>
+                  </a:solidFill>
+                </a:ln>
+              </p:spPr>
+              <p:style>
+                <a:lnRef idx="2">
+                  <a:schemeClr val="accent1">
+                    <a:shade val="50000"/>
+                  </a:schemeClr>
+                </a:lnRef>
+                <a:fillRef idx="1">
+                  <a:schemeClr val="accent1"/>
+                </a:fillRef>
+                <a:effectRef idx="0">
+                  <a:schemeClr val="accent1"/>
+                </a:effectRef>
+                <a:fontRef idx="minor">
+                  <a:schemeClr val="lt1"/>
+                </a:fontRef>
+              </p:style>
+              <p:txBody>
+                <a:bodyPr wrap="square" rtlCol="0" anchor="ctr">
+                  <a:noAutofit/>
+                </a:bodyPr>
+                <a:lstStyle/>
+                <a:p>
+                  <a:pPr algn="ctr"/>
+                  <a:endParaRPr lang="en-US" b="1" dirty="0">
+                    <a:latin typeface="Arial" pitchFamily="34" charset="0"/>
+                    <a:cs typeface="Arial" pitchFamily="34" charset="0"/>
+                  </a:endParaRPr>
+                </a:p>
+              </p:txBody>
+            </p:sp>
+          </p:grpSp>
+          <p:grpSp>
+            <p:nvGrpSpPr>
+              <p:cNvPr id="45" name="Group 44">
+                <a:extLst>
+                  <a:ext uri="{FF2B5EF4-FFF2-40B4-BE49-F238E27FC236}">
+                    <a16:creationId xmlns:a16="http://schemas.microsoft.com/office/drawing/2014/main" id="{4339668B-B9A2-B93A-8DAB-67F0C3184273}"/>
+                  </a:ext>
+                </a:extLst>
+              </p:cNvPr>
+              <p:cNvGrpSpPr/>
+              <p:nvPr/>
+            </p:nvGrpSpPr>
+            <p:grpSpPr>
+              <a:xfrm>
+                <a:off x="2585901" y="3623903"/>
+                <a:ext cx="314326" cy="263814"/>
+                <a:chOff x="3676649" y="3745954"/>
+                <a:chExt cx="314326" cy="263814"/>
+              </a:xfrm>
+            </p:grpSpPr>
+            <p:sp>
+              <p:nvSpPr>
+                <p:cNvPr id="46" name="Rectangle: Rounded Corners 45">
+                  <a:extLst>
+                    <a:ext uri="{FF2B5EF4-FFF2-40B4-BE49-F238E27FC236}">
+                      <a16:creationId xmlns:a16="http://schemas.microsoft.com/office/drawing/2014/main" id="{EE9BC616-4B07-2C95-E0EB-E8ADFFFAB82A}"/>
+                    </a:ext>
+                  </a:extLst>
+                </p:cNvPr>
+                <p:cNvSpPr/>
+                <p:nvPr/>
+              </p:nvSpPr>
+              <p:spPr>
+                <a:xfrm>
+                  <a:off x="3676650" y="3745954"/>
+                  <a:ext cx="314325" cy="263814"/>
+                </a:xfrm>
+                <a:prstGeom prst="roundRect">
+                  <a:avLst>
+                    <a:gd name="adj" fmla="val 9455"/>
+                  </a:avLst>
+                </a:prstGeom>
+                <a:solidFill>
+                  <a:schemeClr val="bg1"/>
+                </a:solidFill>
+                <a:ln>
+                  <a:solidFill>
+                    <a:srgbClr val="265598"/>
+                  </a:solidFill>
+                </a:ln>
+              </p:spPr>
+              <p:style>
+                <a:lnRef idx="2">
+                  <a:schemeClr val="accent1">
+                    <a:shade val="50000"/>
+                  </a:schemeClr>
+                </a:lnRef>
+                <a:fillRef idx="1">
+                  <a:schemeClr val="accent1"/>
+                </a:fillRef>
+                <a:effectRef idx="0">
+                  <a:schemeClr val="accent1"/>
+                </a:effectRef>
+                <a:fontRef idx="minor">
+                  <a:schemeClr val="lt1"/>
+                </a:fontRef>
+              </p:style>
+              <p:txBody>
+                <a:bodyPr rtlCol="0" anchor="ctr"/>
+                <a:lstStyle/>
+                <a:p>
+                  <a:pPr algn="ctr"/>
+                  <a:endParaRPr lang="en-US" b="1" dirty="0">
+                    <a:latin typeface="Arial" pitchFamily="34" charset="0"/>
+                    <a:cs typeface="Arial" pitchFamily="34" charset="0"/>
+                  </a:endParaRPr>
+                </a:p>
+              </p:txBody>
+            </p:sp>
+            <p:sp>
+              <p:nvSpPr>
+                <p:cNvPr id="47" name="Freeform: Shape 46">
+                  <a:extLst>
+                    <a:ext uri="{FF2B5EF4-FFF2-40B4-BE49-F238E27FC236}">
+                      <a16:creationId xmlns:a16="http://schemas.microsoft.com/office/drawing/2014/main" id="{DA8D5F05-D3E3-145E-D7EF-3656A11624E2}"/>
+                    </a:ext>
+                  </a:extLst>
+                </p:cNvPr>
+                <p:cNvSpPr/>
+                <p:nvPr/>
+              </p:nvSpPr>
+              <p:spPr>
+                <a:xfrm>
+                  <a:off x="3676649" y="3745955"/>
+                  <a:ext cx="314325" cy="88475"/>
+                </a:xfrm>
+                <a:custGeom>
+                  <a:avLst/>
+                  <a:gdLst>
+                    <a:gd name="connsiteX0" fmla="*/ 31220 w 409575"/>
+                    <a:gd name="connsiteY0" fmla="*/ 0 h 88475"/>
+                    <a:gd name="connsiteX1" fmla="*/ 378355 w 409575"/>
+                    <a:gd name="connsiteY1" fmla="*/ 0 h 88475"/>
+                    <a:gd name="connsiteX2" fmla="*/ 409575 w 409575"/>
+                    <a:gd name="connsiteY2" fmla="*/ 31220 h 88475"/>
+                    <a:gd name="connsiteX3" fmla="*/ 409575 w 409575"/>
+                    <a:gd name="connsiteY3" fmla="*/ 88475 h 88475"/>
+                    <a:gd name="connsiteX4" fmla="*/ 0 w 409575"/>
+                    <a:gd name="connsiteY4" fmla="*/ 88475 h 88475"/>
+                    <a:gd name="connsiteX5" fmla="*/ 0 w 409575"/>
+                    <a:gd name="connsiteY5" fmla="*/ 31220 h 88475"/>
+                    <a:gd name="connsiteX6" fmla="*/ 31220 w 409575"/>
+                    <a:gd name="connsiteY6" fmla="*/ 0 h 88475"/>
+                  </a:gdLst>
+                  <a:ahLst/>
+                  <a:cxnLst>
+                    <a:cxn ang="0">
+                      <a:pos x="connsiteX0" y="connsiteY0"/>
+                    </a:cxn>
+                    <a:cxn ang="0">
+                      <a:pos x="connsiteX1" y="connsiteY1"/>
+                    </a:cxn>
+                    <a:cxn ang="0">
+                      <a:pos x="connsiteX2" y="connsiteY2"/>
+                    </a:cxn>
+                    <a:cxn ang="0">
+                      <a:pos x="connsiteX3" y="connsiteY3"/>
+                    </a:cxn>
+                    <a:cxn ang="0">
+                      <a:pos x="connsiteX4" y="connsiteY4"/>
+                    </a:cxn>
+                    <a:cxn ang="0">
+                      <a:pos x="connsiteX5" y="connsiteY5"/>
+                    </a:cxn>
+                    <a:cxn ang="0">
+                      <a:pos x="connsiteX6" y="connsiteY6"/>
+                    </a:cxn>
+                  </a:cxnLst>
+                  <a:rect l="l" t="t" r="r" b="b"/>
+                  <a:pathLst>
+                    <a:path w="409575" h="88475">
+                      <a:moveTo>
+                        <a:pt x="31220" y="0"/>
+                      </a:moveTo>
+                      <a:lnTo>
+                        <a:pt x="378355" y="0"/>
+                      </a:lnTo>
+                      <a:cubicBezTo>
+                        <a:pt x="395597" y="0"/>
+                        <a:pt x="409575" y="13978"/>
+                        <a:pt x="409575" y="31220"/>
+                      </a:cubicBezTo>
+                      <a:lnTo>
+                        <a:pt x="409575" y="88475"/>
+                      </a:lnTo>
+                      <a:lnTo>
+                        <a:pt x="0" y="88475"/>
+                      </a:lnTo>
+                      <a:lnTo>
+                        <a:pt x="0" y="31220"/>
+                      </a:lnTo>
+                      <a:cubicBezTo>
+                        <a:pt x="0" y="13978"/>
+                        <a:pt x="13978" y="0"/>
+                        <a:pt x="31220" y="0"/>
+                      </a:cubicBezTo>
+                      <a:close/>
+                    </a:path>
+                  </a:pathLst>
+                </a:custGeom>
+                <a:solidFill>
+                  <a:srgbClr val="C0CAD9"/>
+                </a:solidFill>
+                <a:ln>
+                  <a:solidFill>
+                    <a:srgbClr val="265598"/>
+                  </a:solidFill>
+                </a:ln>
+              </p:spPr>
+              <p:style>
+                <a:lnRef idx="2">
+                  <a:schemeClr val="accent1">
+                    <a:shade val="50000"/>
+                  </a:schemeClr>
+                </a:lnRef>
+                <a:fillRef idx="1">
+                  <a:schemeClr val="accent1"/>
+                </a:fillRef>
+                <a:effectRef idx="0">
+                  <a:schemeClr val="accent1"/>
+                </a:effectRef>
+                <a:fontRef idx="minor">
+                  <a:schemeClr val="lt1"/>
+                </a:fontRef>
+              </p:style>
+              <p:txBody>
+                <a:bodyPr wrap="square" rtlCol="0" anchor="ctr">
+                  <a:noAutofit/>
+                </a:bodyPr>
+                <a:lstStyle/>
+                <a:p>
+                  <a:pPr algn="ctr"/>
+                  <a:endParaRPr lang="en-US" b="1" dirty="0">
+                    <a:latin typeface="Arial" pitchFamily="34" charset="0"/>
+                    <a:cs typeface="Arial" pitchFamily="34" charset="0"/>
+                  </a:endParaRPr>
+                </a:p>
+              </p:txBody>
+            </p:sp>
+          </p:grpSp>
+        </p:grpSp>
+        <p:grpSp>
+          <p:nvGrpSpPr>
+            <p:cNvPr id="31" name="Group 30">
+              <a:extLst>
+                <a:ext uri="{FF2B5EF4-FFF2-40B4-BE49-F238E27FC236}">
+                  <a16:creationId xmlns:a16="http://schemas.microsoft.com/office/drawing/2014/main" id="{05081DB5-22E0-3074-C3F6-72449FC5D43D}"/>
+                </a:ext>
+              </a:extLst>
+            </p:cNvPr>
+            <p:cNvGrpSpPr/>
+            <p:nvPr/>
+          </p:nvGrpSpPr>
+          <p:grpSpPr>
+            <a:xfrm>
+              <a:off x="353300" y="1909423"/>
+              <a:ext cx="1894184" cy="635209"/>
+              <a:chOff x="2162078" y="5203404"/>
+              <a:chExt cx="1894184" cy="635209"/>
+            </a:xfrm>
+          </p:grpSpPr>
+          <p:sp>
+            <p:nvSpPr>
+              <p:cNvPr id="32" name="Rectangle: Rounded Corners 31">
+                <a:extLst>
+                  <a:ext uri="{FF2B5EF4-FFF2-40B4-BE49-F238E27FC236}">
+                    <a16:creationId xmlns:a16="http://schemas.microsoft.com/office/drawing/2014/main" id="{6115F242-AA4B-F92E-0B5C-137DD4123F01}"/>
+                  </a:ext>
+                </a:extLst>
+              </p:cNvPr>
+              <p:cNvSpPr/>
+              <p:nvPr/>
+            </p:nvSpPr>
+            <p:spPr>
+              <a:xfrm>
+                <a:off x="2296825" y="5262541"/>
+                <a:ext cx="1723550" cy="508651"/>
+              </a:xfrm>
+              <a:prstGeom prst="roundRect">
+                <a:avLst>
+                  <a:gd name="adj" fmla="val 8351"/>
+                </a:avLst>
+              </a:prstGeom>
+              <a:solidFill>
+                <a:srgbClr val="283645"/>
+              </a:solidFill>
+              <a:ln>
+                <a:noFill/>
+              </a:ln>
+            </p:spPr>
+            <p:style>
+              <a:lnRef idx="2">
+                <a:schemeClr val="accent1">
+                  <a:shade val="50000"/>
+                </a:schemeClr>
+              </a:lnRef>
+              <a:fillRef idx="1">
+                <a:schemeClr val="accent1"/>
+              </a:fillRef>
+              <a:effectRef idx="0">
+                <a:schemeClr val="accent1"/>
+              </a:effectRef>
+              <a:fontRef idx="minor">
+                <a:schemeClr val="lt1"/>
+              </a:fontRef>
+            </p:style>
+            <p:txBody>
+              <a:bodyPr rtlCol="0" anchor="ctr"/>
+              <a:lstStyle/>
+              <a:p>
+                <a:pPr algn="ctr"/>
+                <a:endParaRPr lang="en-US" b="1" dirty="0">
+                  <a:latin typeface="Arial" pitchFamily="34" charset="0"/>
+                  <a:cs typeface="Arial" pitchFamily="34" charset="0"/>
+                </a:endParaRPr>
+              </a:p>
+            </p:txBody>
+          </p:sp>
+          <p:sp>
+            <p:nvSpPr>
+              <p:cNvPr id="33" name="TextBox 32">
+                <a:extLst>
+                  <a:ext uri="{FF2B5EF4-FFF2-40B4-BE49-F238E27FC236}">
+                    <a16:creationId xmlns:a16="http://schemas.microsoft.com/office/drawing/2014/main" id="{72B1E135-094D-CB0F-AECA-9C8D8D151CB0}"/>
+                  </a:ext>
+                </a:extLst>
+              </p:cNvPr>
+              <p:cNvSpPr txBox="1"/>
+              <p:nvPr/>
+            </p:nvSpPr>
+            <p:spPr>
+              <a:xfrm>
+                <a:off x="2162078" y="5367791"/>
+                <a:ext cx="1894184" cy="470822"/>
+              </a:xfrm>
+              <a:prstGeom prst="rect">
+                <a:avLst/>
+              </a:prstGeom>
+              <a:noFill/>
+            </p:spPr>
+            <p:txBody>
+              <a:bodyPr wrap="none" rtlCol="0">
+                <a:spAutoFit/>
+              </a:bodyPr>
+              <a:lstStyle/>
+              <a:p>
+                <a:pPr algn="ctr"/>
+                <a:r>
+                  <a:rPr lang="en-US" sz="1200" b="1" dirty="0">
+                    <a:solidFill>
+                      <a:srgbClr val="C55A11"/>
+                    </a:solidFill>
+                    <a:latin typeface="Lucida Sans Typewriter" panose="020B0509030504030204" pitchFamily="49" charset="0"/>
+                  </a:rPr>
+                  <a:t> Connector</a:t>
+                </a:r>
+              </a:p>
+            </p:txBody>
+          </p:sp>
+          <p:sp>
+            <p:nvSpPr>
+              <p:cNvPr id="34" name="TextBox 33">
+                <a:extLst>
+                  <a:ext uri="{FF2B5EF4-FFF2-40B4-BE49-F238E27FC236}">
+                    <a16:creationId xmlns:a16="http://schemas.microsoft.com/office/drawing/2014/main" id="{4CD1CD08-5F2E-A476-678F-2BC3B4D5E25B}"/>
+                  </a:ext>
+                </a:extLst>
+              </p:cNvPr>
+              <p:cNvSpPr txBox="1"/>
+              <p:nvPr/>
+            </p:nvSpPr>
+            <p:spPr>
+              <a:xfrm>
+                <a:off x="2277802" y="5203404"/>
+                <a:ext cx="1104032" cy="470822"/>
+              </a:xfrm>
+              <a:prstGeom prst="rect">
+                <a:avLst/>
+              </a:prstGeom>
+              <a:noFill/>
+            </p:spPr>
+            <p:txBody>
+              <a:bodyPr wrap="none" rtlCol="0">
+                <a:spAutoFit/>
+              </a:bodyPr>
+              <a:lstStyle/>
+              <a:p>
+                <a:pPr algn="ctr">
+                  <a:spcAft>
+                    <a:spcPts val="1200"/>
+                  </a:spcAft>
+                </a:pPr>
+                <a:r>
+                  <a:rPr lang="en-US" sz="1200" b="1" dirty="0">
+                    <a:solidFill>
+                      <a:schemeClr val="bg1"/>
+                    </a:solidFill>
+                    <a:latin typeface="Lucida Sans Typewriter" panose="020B0509030504030204" pitchFamily="49" charset="0"/>
+                  </a:rPr>
+                  <a:t>SysML</a:t>
+                </a:r>
+              </a:p>
+            </p:txBody>
+          </p:sp>
+        </p:grpSp>
+      </p:grpSp>
+    </p:spTree>
+    <p:extLst>
+      <p:ext uri="{BB962C8B-B14F-4D97-AF65-F5344CB8AC3E}">
+        <p14:creationId xmlns:p14="http://schemas.microsoft.com/office/powerpoint/2010/main" val="504712214"/>
+      </p:ext>
+    </p:extLst>
+  </p:cSld>
+  <p:clrMapOvr>
+    <a:masterClrMapping/>
+  </p:clrMapOvr>
+</p:sld>
+</file>
+
 <file path=ppt/theme/theme1.xml><?xml version="1.0" encoding="utf-8"?>
 <a:theme xmlns:a="http://schemas.openxmlformats.org/drawingml/2006/main" name="Office Theme">
   <a:themeElements>

</xml_diff>